<commit_message>
Presentación: ideas de futuro (Oye Vento, modo fácil, cobros sin comisión, más innovaciones)
Co-Authored-By: Claude Opus 5.5 <noreply@anthropic.com>
Claude-Session: https://claude.ai/code/session_01264FeNVwnzWhYSciWxK2WJ
</commit_message>
<xml_diff>
--- a/ventas/Vento-presentacion.pptx
+++ b/ventas/Vento-presentacion.pptx
@@ -24,9 +24,13 @@
     <p:sldId id="272" r:id="rId18"/>
     <p:sldId id="273" r:id="rId19"/>
     <p:sldId id="274" r:id="rId20"/>
+    <p:sldId id="275" r:id="rId21"/>
+    <p:sldId id="276" r:id="rId22"/>
+    <p:sldId id="277" r:id="rId23"/>
+    <p:sldId id="278" r:id="rId24"/>
   </p:sldIdLst>
   <p:notesMasterIdLst>
-    <p:notesMasterId r:id="rId21"/>
+    <p:notesMasterId r:id="rId25"/>
   </p:notesMasterIdLst>
   <p:sldSz cx="9144000" cy="5143500"/>
   <p:notesSz cx="5143500" cy="9144000"/>
@@ -125,18 +129,18 @@
   <p:extLst>
     <p:ext uri="{521415D9-36F7-43E2-AB2F-B90AF26B5E84}">
       <p14:sectionLst xmlns:p14="http://schemas.microsoft.com/office/powerpoint/2010/main">
-        <p14:section name="Inicio" id="{b0e82469-7467-4a88-f857-4ba2bf1d37e2}">
+        <p14:section name="Inicio" id="{f4f3bf4c-6c04-ecc1-356a-abfcd7e0dff7}">
           <p14:sldIdLst>
             <p14:sldId id="256"/>
           </p14:sldIdLst>
         </p14:section>
-        <p14:section name="Problema y solución" id="{a58d42bd-4636-2f4f-8cdb-c0213a3b3808}">
+        <p14:section name="Problema y solución" id="{d2517bd0-1327-44d1-9e74-86e362283150}">
           <p14:sldIdLst>
             <p14:sldId id="257"/>
             <p14:sldId id="258"/>
           </p14:sldIdLst>
         </p14:section>
-        <p14:section name="Producto" id="{e838b384-0523-b916-3500-0e752b0d3c49}">
+        <p14:section name="Producto" id="{35775118-699a-e0a6-037d-7b10418c1ef0}">
           <p14:sldIdLst>
             <p14:sldId id="259"/>
             <p14:sldId id="260"/>
@@ -145,14 +149,14 @@
             <p14:sldId id="263"/>
           </p14:sldIdLst>
         </p14:section>
-        <p14:section name="Administración" id="{92d9518b-79ed-476e-9d91-42e18dce0f3f}">
+        <p14:section name="Administración" id="{8e178bf3-a389-4608-6784-b9bd73e86d44}">
           <p14:sldIdLst>
             <p14:sldId id="264"/>
             <p14:sldId id="265"/>
             <p14:sldId id="266"/>
           </p14:sldIdLst>
         </p14:section>
-        <p14:section name="Operación" id="{96d9fdf2-e265-af42-d1f5-55b827129262}">
+        <p14:section name="Operación" id="{a66cb9fc-57ca-3b1a-b359-d8e84ec4de55}">
           <p14:sldIdLst>
             <p14:sldId id="267"/>
             <p14:sldId id="268"/>
@@ -160,16 +164,20 @@
             <p14:sldId id="270"/>
           </p14:sldIdLst>
         </p14:section>
-        <p14:section name="Negocio" id="{e6ab01a7-7be6-349d-7e1f-58b4f9368a11}">
+        <p14:section name="Negocio" id="{024622f9-666c-35b9-b750-f1730bbe8097}">
           <p14:sldIdLst>
             <p14:sldId id="271"/>
             <p14:sldId id="272"/>
           </p14:sldIdLst>
         </p14:section>
-        <p14:section name="Futuro y cierre" id="{84cb3c33-2421-69c2-1b65-c85befbe643c}">
+        <p14:section name="Futuro y cierre" id="{a1578713-fb69-82af-e2a8-8e670d6d3d54}">
           <p14:sldIdLst>
             <p14:sldId id="273"/>
             <p14:sldId id="274"/>
+            <p14:sldId id="275"/>
+            <p14:sldId id="276"/>
+            <p14:sldId id="277"/>
+            <p14:sldId id="278"/>
           </p14:sldIdLst>
         </p14:section>
       </p14:sectionLst>
@@ -1456,7 +1464,7 @@
           <a:p>
             <a:r>
               <a:rPr lang="en-US" dirty="0"/>
-              <a:t/>
+              <a:t>Visión: un asistente de voz siempre atento, como Alexa, pero que conoce las mesas, las cuentas y el inventario del negocio. Hoy ya existen los comandos de voz con el botón del micrófono; la palabra de activación y el equipo propio son el siguiente paso.</a:t>
             </a:r>
             <a:endParaRPr lang="en-US" dirty="0"/>
           </a:p>
@@ -1568,6 +1576,358 @@
             <a:fld id="{F7021451-1387-4CA6-816F-3879F97B5CBC}" type="slidenum">
               <a:rPr lang="en-US"/>
               <a:t>2</a:t>
+            </a:fld>
+            <a:endParaRPr lang="en-US"/>
+          </a:p>
+        </p:txBody>
+      </p:sp>
+    </p:spTree>
+    <p:extLst>
+      <p:ext uri="{BB962C8B-B14F-4D97-AF65-F5344CB8AC3E}">
+        <p14:creationId xmlns:p14="http://schemas.microsoft.com/office/powerpoint/2010/main" val="1024086991"/>
+      </p:ext>
+    </p:extLst>
+  </p:cSld>
+  <p:clrMapOvr>
+    <a:masterClrMapping/>
+  </p:clrMapOvr>
+</p:notes>
+</file>
+
+<file path=ppt/notesSlides/notesSlide20.xml><?xml version="1.0" encoding="utf-8"?>
+<p:notes xmlns:a="http://schemas.openxmlformats.org/drawingml/2006/main" xmlns:r="http://schemas.openxmlformats.org/officeDocument/2006/relationships" xmlns:p="http://schemas.openxmlformats.org/presentationml/2006/main">
+  <p:cSld>
+    <p:spTree>
+      <p:nvGrpSpPr>
+        <p:cNvPr id="1" name=""/>
+        <p:cNvGrpSpPr/>
+        <p:nvPr/>
+      </p:nvGrpSpPr>
+      <p:grpSpPr>
+        <a:xfrm>
+          <a:off x="0" y="0"/>
+          <a:ext cx="0" cy="0"/>
+          <a:chOff x="0" y="0"/>
+          <a:chExt cx="0" cy="0"/>
+        </a:xfrm>
+      </p:grpSpPr>
+      <p:sp>
+        <p:nvSpPr>
+          <p:cNvPr id="2" name="Slide Image Placeholder 1"/>
+          <p:cNvSpPr>
+            <a:spLocks noGrp="1" noRot="1" noChangeAspect="1"/>
+          </p:cNvSpPr>
+          <p:nvPr>
+            <p:ph type="sldImg"/>
+          </p:nvPr>
+        </p:nvSpPr>
+        <p:spPr/>
+      </p:sp>
+      <p:sp>
+        <p:nvSpPr>
+          <p:cNvPr id="3" name="Notes Placeholder 2"/>
+          <p:cNvSpPr>
+            <a:spLocks noGrp="1"/>
+          </p:cNvSpPr>
+          <p:nvPr>
+            <p:ph type="body" idx="1"/>
+          </p:nvPr>
+        </p:nvSpPr>
+        <p:spPr/>
+        <p:txBody>
+          <a:bodyPr/>
+          <a:lstStyle/>
+          <a:p>
+            <a:r>
+              <a:rPr lang="en-US" dirty="0"/>
+              <a:t/>
+            </a:r>
+            <a:endParaRPr lang="en-US" dirty="0"/>
+          </a:p>
+        </p:txBody>
+      </p:sp>
+      <p:sp>
+        <p:nvSpPr>
+          <p:cNvPr id="4" name="Slide Number Placeholder 3"/>
+          <p:cNvSpPr>
+            <a:spLocks noGrp="1"/>
+          </p:cNvSpPr>
+          <p:nvPr>
+            <p:ph type="sldNum" sz="quarter" idx="10"/>
+          </p:nvPr>
+        </p:nvSpPr>
+        <p:spPr/>
+        <p:txBody>
+          <a:bodyPr/>
+          <a:lstStyle/>
+          <a:p>
+            <a:fld id="{F7021451-1387-4CA6-816F-3879F97B5CBC}" type="slidenum">
+              <a:rPr lang="en-US"/>
+              <a:t>20</a:t>
+            </a:fld>
+            <a:endParaRPr lang="en-US"/>
+          </a:p>
+        </p:txBody>
+      </p:sp>
+    </p:spTree>
+    <p:extLst>
+      <p:ext uri="{BB962C8B-B14F-4D97-AF65-F5344CB8AC3E}">
+        <p14:creationId xmlns:p14="http://schemas.microsoft.com/office/powerpoint/2010/main" val="1024086991"/>
+      </p:ext>
+    </p:extLst>
+  </p:cSld>
+  <p:clrMapOvr>
+    <a:masterClrMapping/>
+  </p:clrMapOvr>
+</p:notes>
+</file>
+
+<file path=ppt/notesSlides/notesSlide21.xml><?xml version="1.0" encoding="utf-8"?>
+<p:notes xmlns:a="http://schemas.openxmlformats.org/drawingml/2006/main" xmlns:r="http://schemas.openxmlformats.org/officeDocument/2006/relationships" xmlns:p="http://schemas.openxmlformats.org/presentationml/2006/main">
+  <p:cSld>
+    <p:spTree>
+      <p:nvGrpSpPr>
+        <p:cNvPr id="1" name=""/>
+        <p:cNvGrpSpPr/>
+        <p:nvPr/>
+      </p:nvGrpSpPr>
+      <p:grpSpPr>
+        <a:xfrm>
+          <a:off x="0" y="0"/>
+          <a:ext cx="0" cy="0"/>
+          <a:chOff x="0" y="0"/>
+          <a:chExt cx="0" cy="0"/>
+        </a:xfrm>
+      </p:grpSpPr>
+      <p:sp>
+        <p:nvSpPr>
+          <p:cNvPr id="2" name="Slide Image Placeholder 1"/>
+          <p:cNvSpPr>
+            <a:spLocks noGrp="1" noRot="1" noChangeAspect="1"/>
+          </p:cNvSpPr>
+          <p:nvPr>
+            <p:ph type="sldImg"/>
+          </p:nvPr>
+        </p:nvSpPr>
+        <p:spPr/>
+      </p:sp>
+      <p:sp>
+        <p:nvSpPr>
+          <p:cNvPr id="3" name="Notes Placeholder 2"/>
+          <p:cNvSpPr>
+            <a:spLocks noGrp="1"/>
+          </p:cNvSpPr>
+          <p:nvPr>
+            <p:ph type="body" idx="1"/>
+          </p:nvPr>
+        </p:nvSpPr>
+        <p:spPr/>
+        <p:txBody>
+          <a:bodyPr/>
+          <a:lstStyle/>
+          <a:p>
+            <a:r>
+              <a:rPr lang="en-US" dirty="0"/>
+              <a:t>Vento no cobra comisión por venta ni por verificar el pago: el dinero va directo a la cuenta Nequi, Daviplata o Bre-B del negocio. Las tarifas propias de cada banco o billetera, si las hay, las define la entidad.</a:t>
+            </a:r>
+            <a:endParaRPr lang="en-US" dirty="0"/>
+          </a:p>
+        </p:txBody>
+      </p:sp>
+      <p:sp>
+        <p:nvSpPr>
+          <p:cNvPr id="4" name="Slide Number Placeholder 3"/>
+          <p:cNvSpPr>
+            <a:spLocks noGrp="1"/>
+          </p:cNvSpPr>
+          <p:nvPr>
+            <p:ph type="sldNum" sz="quarter" idx="10"/>
+          </p:nvPr>
+        </p:nvSpPr>
+        <p:spPr/>
+        <p:txBody>
+          <a:bodyPr/>
+          <a:lstStyle/>
+          <a:p>
+            <a:fld id="{F7021451-1387-4CA6-816F-3879F97B5CBC}" type="slidenum">
+              <a:rPr lang="en-US"/>
+              <a:t>21</a:t>
+            </a:fld>
+            <a:endParaRPr lang="en-US"/>
+          </a:p>
+        </p:txBody>
+      </p:sp>
+    </p:spTree>
+    <p:extLst>
+      <p:ext uri="{BB962C8B-B14F-4D97-AF65-F5344CB8AC3E}">
+        <p14:creationId xmlns:p14="http://schemas.microsoft.com/office/powerpoint/2010/main" val="1024086991"/>
+      </p:ext>
+    </p:extLst>
+  </p:cSld>
+  <p:clrMapOvr>
+    <a:masterClrMapping/>
+  </p:clrMapOvr>
+</p:notes>
+</file>
+
+<file path=ppt/notesSlides/notesSlide22.xml><?xml version="1.0" encoding="utf-8"?>
+<p:notes xmlns:a="http://schemas.openxmlformats.org/drawingml/2006/main" xmlns:r="http://schemas.openxmlformats.org/officeDocument/2006/relationships" xmlns:p="http://schemas.openxmlformats.org/presentationml/2006/main">
+  <p:cSld>
+    <p:spTree>
+      <p:nvGrpSpPr>
+        <p:cNvPr id="1" name=""/>
+        <p:cNvGrpSpPr/>
+        <p:nvPr/>
+      </p:nvGrpSpPr>
+      <p:grpSpPr>
+        <a:xfrm>
+          <a:off x="0" y="0"/>
+          <a:ext cx="0" cy="0"/>
+          <a:chOff x="0" y="0"/>
+          <a:chExt cx="0" cy="0"/>
+        </a:xfrm>
+      </p:grpSpPr>
+      <p:sp>
+        <p:nvSpPr>
+          <p:cNvPr id="2" name="Slide Image Placeholder 1"/>
+          <p:cNvSpPr>
+            <a:spLocks noGrp="1" noRot="1" noChangeAspect="1"/>
+          </p:cNvSpPr>
+          <p:nvPr>
+            <p:ph type="sldImg"/>
+          </p:nvPr>
+        </p:nvSpPr>
+        <p:spPr/>
+      </p:sp>
+      <p:sp>
+        <p:nvSpPr>
+          <p:cNvPr id="3" name="Notes Placeholder 2"/>
+          <p:cNvSpPr>
+            <a:spLocks noGrp="1"/>
+          </p:cNvSpPr>
+          <p:nvPr>
+            <p:ph type="body" idx="1"/>
+          </p:nvPr>
+        </p:nvSpPr>
+        <p:spPr/>
+        <p:txBody>
+          <a:bodyPr/>
+          <a:lstStyle/>
+          <a:p>
+            <a:r>
+              <a:rPr lang="en-US" dirty="0"/>
+              <a:t/>
+            </a:r>
+            <a:endParaRPr lang="en-US" dirty="0"/>
+          </a:p>
+        </p:txBody>
+      </p:sp>
+      <p:sp>
+        <p:nvSpPr>
+          <p:cNvPr id="4" name="Slide Number Placeholder 3"/>
+          <p:cNvSpPr>
+            <a:spLocks noGrp="1"/>
+          </p:cNvSpPr>
+          <p:nvPr>
+            <p:ph type="sldNum" sz="quarter" idx="10"/>
+          </p:nvPr>
+        </p:nvSpPr>
+        <p:spPr/>
+        <p:txBody>
+          <a:bodyPr/>
+          <a:lstStyle/>
+          <a:p>
+            <a:fld id="{F7021451-1387-4CA6-816F-3879F97B5CBC}" type="slidenum">
+              <a:rPr lang="en-US"/>
+              <a:t>22</a:t>
+            </a:fld>
+            <a:endParaRPr lang="en-US"/>
+          </a:p>
+        </p:txBody>
+      </p:sp>
+    </p:spTree>
+    <p:extLst>
+      <p:ext uri="{BB962C8B-B14F-4D97-AF65-F5344CB8AC3E}">
+        <p14:creationId xmlns:p14="http://schemas.microsoft.com/office/powerpoint/2010/main" val="1024086991"/>
+      </p:ext>
+    </p:extLst>
+  </p:cSld>
+  <p:clrMapOvr>
+    <a:masterClrMapping/>
+  </p:clrMapOvr>
+</p:notes>
+</file>
+
+<file path=ppt/notesSlides/notesSlide23.xml><?xml version="1.0" encoding="utf-8"?>
+<p:notes xmlns:a="http://schemas.openxmlformats.org/drawingml/2006/main" xmlns:r="http://schemas.openxmlformats.org/officeDocument/2006/relationships" xmlns:p="http://schemas.openxmlformats.org/presentationml/2006/main">
+  <p:cSld>
+    <p:spTree>
+      <p:nvGrpSpPr>
+        <p:cNvPr id="1" name=""/>
+        <p:cNvGrpSpPr/>
+        <p:nvPr/>
+      </p:nvGrpSpPr>
+      <p:grpSpPr>
+        <a:xfrm>
+          <a:off x="0" y="0"/>
+          <a:ext cx="0" cy="0"/>
+          <a:chOff x="0" y="0"/>
+          <a:chExt cx="0" cy="0"/>
+        </a:xfrm>
+      </p:grpSpPr>
+      <p:sp>
+        <p:nvSpPr>
+          <p:cNvPr id="2" name="Slide Image Placeholder 1"/>
+          <p:cNvSpPr>
+            <a:spLocks noGrp="1" noRot="1" noChangeAspect="1"/>
+          </p:cNvSpPr>
+          <p:nvPr>
+            <p:ph type="sldImg"/>
+          </p:nvPr>
+        </p:nvSpPr>
+        <p:spPr/>
+      </p:sp>
+      <p:sp>
+        <p:nvSpPr>
+          <p:cNvPr id="3" name="Notes Placeholder 2"/>
+          <p:cNvSpPr>
+            <a:spLocks noGrp="1"/>
+          </p:cNvSpPr>
+          <p:nvPr>
+            <p:ph type="body" idx="1"/>
+          </p:nvPr>
+        </p:nvSpPr>
+        <p:spPr/>
+        <p:txBody>
+          <a:bodyPr/>
+          <a:lstStyle/>
+          <a:p>
+            <a:r>
+              <a:rPr lang="en-US" dirty="0"/>
+              <a:t/>
+            </a:r>
+            <a:endParaRPr lang="en-US" dirty="0"/>
+          </a:p>
+        </p:txBody>
+      </p:sp>
+      <p:sp>
+        <p:nvSpPr>
+          <p:cNvPr id="4" name="Slide Number Placeholder 3"/>
+          <p:cNvSpPr>
+            <a:spLocks noGrp="1"/>
+          </p:cNvSpPr>
+          <p:nvPr>
+            <p:ph type="sldNum" sz="quarter" idx="10"/>
+          </p:nvPr>
+        </p:nvSpPr>
+        <p:spPr/>
+        <p:txBody>
+          <a:bodyPr/>
+          <a:lstStyle/>
+          <a:p>
+            <a:fld id="{F7021451-1387-4CA6-816F-3879F97B5CBC}" type="slidenum">
+              <a:rPr lang="en-US"/>
+              <a:t>23</a:t>
             </a:fld>
             <a:endParaRPr lang="en-US"/>
           </a:p>
@@ -11977,9 +12337,162 @@
           <a:chExt cx="0" cy="0"/>
         </a:xfrm>
       </p:grpSpPr>
+      <p:sp>
+        <p:nvSpPr>
+          <p:cNvPr id="2" name="Text 0"/>
+          <p:cNvSpPr/>
+          <p:nvPr>
+            <p:ph idx="100" type="title" hasCustomPrompt="1"/>
+          </p:nvPr>
+        </p:nvSpPr>
+        <p:spPr>
+          <a:xfrm>
+            <a:off x="548640" y="320040"/>
+            <a:ext cx="8046720" cy="685800"/>
+          </a:xfrm>
+          <a:prstGeom prst="rect">
+            <a:avLst/>
+          </a:prstGeom>
+          <a:noFill/>
+          <a:ln/>
+        </p:spPr>
+        <p:txBody>
+          <a:bodyPr wrap="square" lIns="0" tIns="0" rIns="0" bIns="0" rtlCol="0" anchor="ctr"/>
+          <a:lstStyle/>
+          <a:p>
+            <a:pPr indent="0" marL="0">
+              <a:buNone/>
+            </a:pPr>
+            <a:r>
+              <a:rPr lang="en-US" sz="3000" b="1" dirty="0">
+                <a:solidFill>
+                  <a:schemeClr val="bg1"/>
+                </a:solidFill>
+              </a:rPr>
+              <a:t>«Oye Vento»: manos libres</a:t>
+            </a:r>
+            <a:endParaRPr lang="en-US" sz="3000" dirty="0"/>
+          </a:p>
+        </p:txBody>
+      </p:sp>
+      <p:sp>
+        <p:nvSpPr>
+          <p:cNvPr id="3" name="Etiqueta futuro fondo"/>
+          <p:cNvSpPr/>
+          <p:nvPr/>
+        </p:nvSpPr>
+        <p:spPr>
+          <a:xfrm>
+            <a:off x="6263640" y="457200"/>
+            <a:ext cx="2331720" cy="329184"/>
+          </a:xfrm>
+          <a:prstGeom prst="roundRect">
+            <a:avLst>
+              <a:gd name="adj" fmla="val 50000"/>
+            </a:avLst>
+          </a:prstGeom>
+          <a:solidFill>
+            <a:srgbClr val="2A1F4A"/>
+          </a:solidFill>
+          <a:ln w="12700">
+            <a:solidFill>
+              <a:srgbClr val="7C3AED"/>
+            </a:solidFill>
+            <a:prstDash val="solid"/>
+          </a:ln>
+        </p:spPr>
+      </p:sp>
+      <p:sp>
+        <p:nvSpPr>
+          <p:cNvPr id="4" name="Etiqueta futuro"/>
+          <p:cNvSpPr txBox="1"/>
+          <p:nvPr/>
+        </p:nvSpPr>
+        <p:spPr>
+          <a:xfrm>
+            <a:off x="6263640" y="457200"/>
+            <a:ext cx="2331720" cy="329184"/>
+          </a:xfrm>
+          <a:prstGeom prst="rect">
+            <a:avLst/>
+          </a:prstGeom>
+          <a:noFill/>
+          <a:ln/>
+        </p:spPr>
+        <p:txBody>
+          <a:bodyPr wrap="square" lIns="0" tIns="0" rIns="0" bIns="0" rtlCol="0" anchor="ctr"/>
+          <a:lstStyle/>
+          <a:p>
+            <a:pPr algn="ctr" indent="0" marL="0">
+              <a:buNone/>
+            </a:pPr>
+            <a:r>
+              <a:rPr lang="en-US" sz="900" b="1" dirty="0">
+                <a:solidFill>
+                  <a:srgbClr val="C4B5FD"/>
+                </a:solidFill>
+              </a:rPr>
+              <a:t>EN DESARROLLO · IDEA DE FUTURO</a:t>
+            </a:r>
+            <a:endParaRPr lang="en-US" sz="900" dirty="0"/>
+          </a:p>
+        </p:txBody>
+      </p:sp>
+      <p:sp>
+        <p:nvSpPr>
+          <p:cNvPr id="5" name="Panel asistente"/>
+          <p:cNvSpPr/>
+          <p:nvPr/>
+        </p:nvSpPr>
+        <p:spPr>
+          <a:xfrm>
+            <a:off x="548640" y="1188720"/>
+            <a:ext cx="3017520" cy="3429000"/>
+          </a:xfrm>
+          <a:prstGeom prst="roundRect">
+            <a:avLst>
+              <a:gd name="adj" fmla="val 3636"/>
+            </a:avLst>
+          </a:prstGeom>
+          <a:solidFill>
+            <a:srgbClr val="2A1F4A"/>
+          </a:solidFill>
+          <a:ln w="9525">
+            <a:solidFill>
+              <a:srgbClr val="2E2A44"/>
+            </a:solidFill>
+            <a:prstDash val="solid"/>
+          </a:ln>
+        </p:spPr>
+      </p:sp>
+      <p:sp>
+        <p:nvSpPr>
+          <p:cNvPr id="6" name="Asistente círculo"/>
+          <p:cNvSpPr/>
+          <p:nvPr/>
+        </p:nvSpPr>
+        <p:spPr>
+          <a:xfrm>
+            <a:off x="822960" y="1463040"/>
+            <a:ext cx="777240" cy="777240"/>
+          </a:xfrm>
+          <a:prstGeom prst="ellipse">
+            <a:avLst/>
+          </a:prstGeom>
+          <a:solidFill>
+            <a:srgbClr val="7C3AED"/>
+          </a:solidFill>
+          <a:ln w="12700">
+            <a:solidFill>
+              <a:srgbClr val="7C3AED"/>
+            </a:solidFill>
+            <a:prstDash val="solid"/>
+          </a:ln>
+        </p:spPr>
+      </p:sp>
       <p:pic>
         <p:nvPicPr>
-          <p:cNvPr id="2" name="Logo Vento cierre" descr="preencoded.png">    </p:cNvPr>
+          <p:cNvPr id="7" name="Asistente ícono" descr="preencoded.png">    </p:cNvPr>
           <p:cNvPicPr>
             <a:picLocks noChangeAspect="1"/>
           </p:cNvPicPr>
@@ -11993,8 +12506,8 @@
         </p:blipFill>
         <p:spPr>
           <a:xfrm>
-            <a:off x="548640" y="502920"/>
-            <a:ext cx="685800" cy="685800"/>
+            <a:off x="1009498" y="1649578"/>
+            <a:ext cx="404165" cy="404165"/>
           </a:xfrm>
           <a:prstGeom prst="rect">
             <a:avLst/>
@@ -12003,151 +12516,143 @@
       </p:pic>
       <p:sp>
         <p:nvSpPr>
-          <p:cNvPr id="3" name="Text 0"/>
+          <p:cNvPr id="8" name="Frase usuario"/>
+          <p:cNvSpPr txBox="1"/>
+          <p:nvPr/>
+        </p:nvSpPr>
+        <p:spPr>
+          <a:xfrm>
+            <a:off x="822960" y="2377440"/>
+            <a:ext cx="2560320" cy="822960"/>
+          </a:xfrm>
+          <a:prstGeom prst="rect">
+            <a:avLst/>
+          </a:prstGeom>
+          <a:noFill/>
+          <a:ln/>
+        </p:spPr>
+        <p:txBody>
+          <a:bodyPr wrap="square" lIns="0" tIns="0" rIns="0" bIns="0" rtlCol="0" anchor="t"/>
+          <a:lstStyle/>
+          <a:p>
+            <a:pPr indent="0" marL="0">
+              <a:buNone/>
+            </a:pPr>
+            <a:r>
+              <a:rPr lang="en-US" sz="1800" b="1" i="1" dirty="0">
+                <a:solidFill>
+                  <a:srgbClr val="FFFFFF"/>
+                </a:solidFill>
+                <a:latin typeface="Arial" pitchFamily="34" charset="0"/>
+                <a:ea typeface="Arial" pitchFamily="34" charset="-122"/>
+                <a:cs typeface="Arial" pitchFamily="34" charset="-120"/>
+              </a:rPr>
+              <a:t>“Oye Vento, ¿cuánto debe la mesa 4?”</a:t>
+            </a:r>
+            <a:endParaRPr lang="en-US" sz="1800" dirty="0"/>
+          </a:p>
+        </p:txBody>
+      </p:sp>
+      <p:sp>
+        <p:nvSpPr>
+          <p:cNvPr id="9" name="Respuesta Vento"/>
+          <p:cNvSpPr txBox="1"/>
+          <p:nvPr/>
+        </p:nvSpPr>
+        <p:spPr>
+          <a:xfrm>
+            <a:off x="822960" y="3291840"/>
+            <a:ext cx="2560320" cy="548640"/>
+          </a:xfrm>
+          <a:prstGeom prst="rect">
+            <a:avLst/>
+          </a:prstGeom>
+          <a:noFill/>
+          <a:ln/>
+        </p:spPr>
+        <p:txBody>
+          <a:bodyPr wrap="square" lIns="0" tIns="0" rIns="0" bIns="0" rtlCol="0" anchor="t"/>
+          <a:lstStyle/>
+          <a:p>
+            <a:pPr indent="0" marL="0">
+              <a:buNone/>
+            </a:pPr>
+            <a:r>
+              <a:rPr lang="en-US" sz="1500" b="1" dirty="0">
+                <a:solidFill>
+                  <a:srgbClr val="34D399"/>
+                </a:solidFill>
+              </a:rPr>
+              <a:t>🔊 “La mesa 4 debe 86 mil pesos.”</a:t>
+            </a:r>
+            <a:endParaRPr lang="en-US" sz="1500" dirty="0"/>
+          </a:p>
+        </p:txBody>
+      </p:sp>
+      <p:sp>
+        <p:nvSpPr>
+          <p:cNvPr id="10" name="Comparación"/>
+          <p:cNvSpPr txBox="1"/>
+          <p:nvPr/>
+        </p:nvSpPr>
+        <p:spPr>
+          <a:xfrm>
+            <a:off x="822960" y="3977640"/>
+            <a:ext cx="2560320" cy="457200"/>
+          </a:xfrm>
+          <a:prstGeom prst="rect">
+            <a:avLst/>
+          </a:prstGeom>
+          <a:noFill/>
+          <a:ln/>
+        </p:spPr>
+        <p:txBody>
+          <a:bodyPr wrap="square" lIns="0" tIns="0" rIns="0" bIns="0" rtlCol="0" anchor="t"/>
+          <a:lstStyle/>
+          <a:p>
+            <a:pPr indent="0" marL="0">
+              <a:buNone/>
+            </a:pPr>
+            <a:r>
+              <a:rPr lang="en-US" sz="1200" dirty="0">
+                <a:solidFill>
+                  <a:srgbClr val="A9A6BD"/>
+                </a:solidFill>
+              </a:rPr>
+              <a:t>Como Alexa, pero hecho para tu negocio.</a:t>
+            </a:r>
+            <a:endParaRPr lang="en-US" sz="1200" dirty="0"/>
+          </a:p>
+        </p:txBody>
+      </p:sp>
+      <p:sp>
+        <p:nvSpPr>
+          <p:cNvPr id="11" name="Manos libres 1 círculo"/>
           <p:cNvSpPr/>
-          <p:nvPr>
-            <p:ph idx="100" type="title" hasCustomPrompt="1"/>
-          </p:nvPr>
-        </p:nvSpPr>
-        <p:spPr>
-          <a:xfrm>
-            <a:off x="548640" y="1234440"/>
-            <a:ext cx="4572000" cy="1188720"/>
-          </a:xfrm>
-          <a:prstGeom prst="rect">
-            <a:avLst/>
-          </a:prstGeom>
-          <a:noFill/>
-          <a:ln/>
-        </p:spPr>
-        <p:txBody>
-          <a:bodyPr wrap="square" lIns="0" tIns="0" rIns="0" bIns="0" rtlCol="0" anchor="b"/>
-          <a:lstStyle/>
-          <a:p>
-            <a:pPr indent="0" marL="0">
-              <a:buNone/>
-            </a:pPr>
-            <a:r>
-              <a:rPr lang="en-US" sz="3600" b="1" dirty="0">
-                <a:solidFill>
-                  <a:schemeClr val="bg1"/>
-                </a:solidFill>
-              </a:rPr>
-              <a:t>Vento trabaja por ti</a:t>
-            </a:r>
-            <a:endParaRPr lang="en-US" sz="5400" dirty="0"/>
-          </a:p>
-        </p:txBody>
-      </p:sp>
-      <p:sp>
-        <p:nvSpPr>
-          <p:cNvPr id="4" name="Text 0"/>
-          <p:cNvSpPr/>
-          <p:nvPr>
-            <p:ph idx="101" type="body" hasCustomPrompt="1"/>
-          </p:nvPr>
-        </p:nvSpPr>
-        <p:spPr>
-          <a:xfrm>
-            <a:off x="548640" y="2514600"/>
-            <a:ext cx="4480560" cy="1463040"/>
-          </a:xfrm>
-          <a:prstGeom prst="rect">
-            <a:avLst/>
-          </a:prstGeom>
-          <a:noFill/>
-          <a:ln/>
-        </p:spPr>
-        <p:txBody>
-          <a:bodyPr wrap="square" lIns="0" tIns="0" rIns="0" bIns="0" rtlCol="0" anchor="t"/>
-          <a:lstStyle/>
-          <a:p>
-            <a:pPr indent="0" marL="0">
-              <a:spcAft>
-                <a:spcPts val="1000"/>
-              </a:spcAft>
-              <a:buNone/>
-            </a:pPr>
-            <a:r>
-              <a:rPr lang="en-US" sz="1800" b="1" dirty="0">
-                <a:solidFill>
-                  <a:schemeClr val="accent2"/>
-                </a:solidFill>
-              </a:rPr>
-              <a:t>Pruébalo gratis hoy en tu negocio.</a:t>
-            </a:r>
-            <a:endParaRPr lang="en-US" sz="1800" dirty="0"/>
-          </a:p>
-          <a:p>
-            <a:pPr indent="0" marL="0">
-              <a:spcAft>
-                <a:spcPts val="400"/>
-              </a:spcAft>
-              <a:buNone/>
-            </a:pPr>
-            <a:r>
-              <a:rPr lang="en-US" sz="1500" dirty="0">
-                <a:solidFill>
-                  <a:srgbClr val="34D399"/>
-                </a:solidFill>
-              </a:rPr>
-              <a:t>WhatsApp: +57 313 895 0277</a:t>
-            </a:r>
-            <a:endParaRPr lang="en-US" sz="1800" dirty="0"/>
-          </a:p>
-          <a:p>
-            <a:pPr indent="0" marL="0">
-              <a:buNone/>
-            </a:pPr>
-            <a:r>
-              <a:rPr lang="en-US" sz="1300" dirty="0">
-                <a:solidFill>
-                  <a:srgbClr val="A9A6BD"/>
-                </a:solidFill>
-              </a:rPr>
-              <a:t>cristhianlujan45-blip.github.io/cuentas</a:t>
-            </a:r>
-            <a:endParaRPr lang="en-US" sz="1800" dirty="0"/>
-          </a:p>
-        </p:txBody>
-      </p:sp>
-      <p:sp>
-        <p:nvSpPr>
-          <p:cNvPr id="5" name="Pantalla de cuenta marco"/>
-          <p:cNvSpPr/>
-          <p:nvPr/>
-        </p:nvSpPr>
-        <p:spPr>
-          <a:xfrm>
-            <a:off x="5925312" y="347472"/>
-            <a:ext cx="2135037" cy="4471416"/>
-          </a:xfrm>
-          <a:prstGeom prst="roundRect">
-            <a:avLst>
-              <a:gd name="adj" fmla="val 9422"/>
-            </a:avLst>
+          <p:nvPr/>
+        </p:nvSpPr>
+        <p:spPr>
+          <a:xfrm>
+            <a:off x="3840480" y="1234440"/>
+            <a:ext cx="566928" cy="566928"/>
+          </a:xfrm>
+          <a:prstGeom prst="ellipse">
+            <a:avLst/>
           </a:prstGeom>
           <a:solidFill>
-            <a:srgbClr val="05050A"/>
+            <a:srgbClr val="7C3AED"/>
           </a:solidFill>
-          <a:ln w="19050">
+          <a:ln w="12700">
             <a:solidFill>
-              <a:srgbClr val="4C3A8F"/>
+              <a:srgbClr val="7C3AED"/>
             </a:solidFill>
             <a:prstDash val="solid"/>
           </a:ln>
-          <a:effectLst>
-            <a:outerShdw sx="100000" sy="100000" kx="0" ky="0" algn="bl" rotWithShape="0" blurRad="228600" dist="25400" dir="5400000">
-              <a:srgbClr val="7C3AED">
-                <a:alpha val="35000"/>
-              </a:srgbClr>
-            </a:outerShdw>
-          </a:effectLst>
         </p:spPr>
       </p:sp>
       <p:pic>
         <p:nvPicPr>
-          <p:cNvPr id="6" name="Pantalla de cuenta" descr="preencoded.png">    </p:cNvPr>
+          <p:cNvPr id="12" name="Manos libres 1 ícono" descr="preencoded.png">    </p:cNvPr>
           <p:cNvPicPr>
             <a:picLocks noChangeAspect="1"/>
           </p:cNvPicPr>
@@ -12161,14 +12666,506 @@
         </p:blipFill>
         <p:spPr>
           <a:xfrm>
-            <a:off x="5989320" y="411480"/>
-            <a:ext cx="2007021" cy="4343400"/>
+            <a:off x="3976543" y="1370503"/>
+            <a:ext cx="294803" cy="294803"/>
           </a:xfrm>
           <a:prstGeom prst="rect">
             <a:avLst/>
           </a:prstGeom>
         </p:spPr>
       </p:pic>
+      <p:sp>
+        <p:nvSpPr>
+          <p:cNvPr id="13" name="Manos libres título 1"/>
+          <p:cNvSpPr txBox="1"/>
+          <p:nvPr/>
+        </p:nvSpPr>
+        <p:spPr>
+          <a:xfrm>
+            <a:off x="3840480" y="1920240"/>
+            <a:ext cx="2240280" cy="292608"/>
+          </a:xfrm>
+          <a:prstGeom prst="rect">
+            <a:avLst/>
+          </a:prstGeom>
+          <a:noFill/>
+          <a:ln/>
+        </p:spPr>
+        <p:txBody>
+          <a:bodyPr wrap="square" lIns="0" tIns="0" rIns="0" bIns="0" rtlCol="0" anchor="ctr"/>
+          <a:lstStyle/>
+          <a:p>
+            <a:pPr indent="0" marL="0">
+              <a:buNone/>
+            </a:pPr>
+            <a:r>
+              <a:rPr lang="en-US" sz="1500" b="1" dirty="0">
+                <a:solidFill>
+                  <a:srgbClr val="FFFFFF"/>
+                </a:solidFill>
+                <a:latin typeface="Arial" pitchFamily="34" charset="0"/>
+                <a:ea typeface="Arial" pitchFamily="34" charset="-122"/>
+                <a:cs typeface="Arial" pitchFamily="34" charset="-120"/>
+              </a:rPr>
+              <a:t>Palabra de activación</a:t>
+            </a:r>
+            <a:endParaRPr lang="en-US" sz="1500" dirty="0"/>
+          </a:p>
+        </p:txBody>
+      </p:sp>
+      <p:sp>
+        <p:nvSpPr>
+          <p:cNvPr id="14" name="Manos libres texto 1"/>
+          <p:cNvSpPr txBox="1"/>
+          <p:nvPr/>
+        </p:nvSpPr>
+        <p:spPr>
+          <a:xfrm>
+            <a:off x="3840480" y="2221992"/>
+            <a:ext cx="2240280" cy="548640"/>
+          </a:xfrm>
+          <a:prstGeom prst="rect">
+            <a:avLst/>
+          </a:prstGeom>
+          <a:noFill/>
+          <a:ln/>
+        </p:spPr>
+        <p:txBody>
+          <a:bodyPr wrap="square" lIns="0" tIns="0" rIns="0" bIns="0" rtlCol="0" anchor="t"/>
+          <a:lstStyle/>
+          <a:p>
+            <a:pPr indent="0" marL="0">
+              <a:buNone/>
+            </a:pPr>
+            <a:r>
+              <a:rPr lang="en-US" sz="1200" dirty="0">
+                <a:solidFill>
+                  <a:srgbClr val="A9A6BD"/>
+                </a:solidFill>
+              </a:rPr>
+              <a:t>Dices «Oye Vento» y escucha, sin tocar la pantalla.</a:t>
+            </a:r>
+            <a:endParaRPr lang="en-US" sz="1200" dirty="0"/>
+          </a:p>
+        </p:txBody>
+      </p:sp>
+      <p:sp>
+        <p:nvSpPr>
+          <p:cNvPr id="15" name="Manos libres 2 círculo"/>
+          <p:cNvSpPr/>
+          <p:nvPr/>
+        </p:nvSpPr>
+        <p:spPr>
+          <a:xfrm>
+            <a:off x="6263640" y="1234440"/>
+            <a:ext cx="566928" cy="566928"/>
+          </a:xfrm>
+          <a:prstGeom prst="ellipse">
+            <a:avLst/>
+          </a:prstGeom>
+          <a:solidFill>
+            <a:srgbClr val="7C3AED"/>
+          </a:solidFill>
+          <a:ln w="12700">
+            <a:solidFill>
+              <a:srgbClr val="7C3AED"/>
+            </a:solidFill>
+            <a:prstDash val="solid"/>
+          </a:ln>
+        </p:spPr>
+      </p:sp>
+      <p:pic>
+        <p:nvPicPr>
+          <p:cNvPr id="16" name="Manos libres 2 ícono" descr="preencoded.png">    </p:cNvPr>
+          <p:cNvPicPr>
+            <a:picLocks noChangeAspect="1"/>
+          </p:cNvPicPr>
+          <p:nvPr/>
+        </p:nvPicPr>
+        <p:blipFill>
+          <a:blip r:embed="rId3"/>
+          <a:stretch>
+            <a:fillRect/>
+          </a:stretch>
+        </p:blipFill>
+        <p:spPr>
+          <a:xfrm>
+            <a:off x="6399703" y="1370503"/>
+            <a:ext cx="294803" cy="294803"/>
+          </a:xfrm>
+          <a:prstGeom prst="rect">
+            <a:avLst/>
+          </a:prstGeom>
+        </p:spPr>
+      </p:pic>
+      <p:sp>
+        <p:nvSpPr>
+          <p:cNvPr id="17" name="Manos libres título 2"/>
+          <p:cNvSpPr txBox="1"/>
+          <p:nvPr/>
+        </p:nvSpPr>
+        <p:spPr>
+          <a:xfrm>
+            <a:off x="6263640" y="1920240"/>
+            <a:ext cx="2240280" cy="292608"/>
+          </a:xfrm>
+          <a:prstGeom prst="rect">
+            <a:avLst/>
+          </a:prstGeom>
+          <a:noFill/>
+          <a:ln/>
+        </p:spPr>
+        <p:txBody>
+          <a:bodyPr wrap="square" lIns="0" tIns="0" rIns="0" bIns="0" rtlCol="0" anchor="ctr"/>
+          <a:lstStyle/>
+          <a:p>
+            <a:pPr indent="0" marL="0">
+              <a:buNone/>
+            </a:pPr>
+            <a:r>
+              <a:rPr lang="en-US" sz="1500" b="1" dirty="0">
+                <a:solidFill>
+                  <a:srgbClr val="FFFFFF"/>
+                </a:solidFill>
+                <a:latin typeface="Arial" pitchFamily="34" charset="0"/>
+                <a:ea typeface="Arial" pitchFamily="34" charset="-122"/>
+                <a:cs typeface="Arial" pitchFamily="34" charset="-120"/>
+              </a:rPr>
+              <a:t>Responde en voz alta</a:t>
+            </a:r>
+            <a:endParaRPr lang="en-US" sz="1500" dirty="0"/>
+          </a:p>
+        </p:txBody>
+      </p:sp>
+      <p:sp>
+        <p:nvSpPr>
+          <p:cNvPr id="18" name="Manos libres texto 2"/>
+          <p:cNvSpPr txBox="1"/>
+          <p:nvPr/>
+        </p:nvSpPr>
+        <p:spPr>
+          <a:xfrm>
+            <a:off x="6263640" y="2221992"/>
+            <a:ext cx="2240280" cy="548640"/>
+          </a:xfrm>
+          <a:prstGeom prst="rect">
+            <a:avLst/>
+          </a:prstGeom>
+          <a:noFill/>
+          <a:ln/>
+        </p:spPr>
+        <p:txBody>
+          <a:bodyPr wrap="square" lIns="0" tIns="0" rIns="0" bIns="0" rtlCol="0" anchor="t"/>
+          <a:lstStyle/>
+          <a:p>
+            <a:pPr indent="0" marL="0">
+              <a:buNone/>
+            </a:pPr>
+            <a:r>
+              <a:rPr lang="en-US" sz="1200" dirty="0">
+                <a:solidFill>
+                  <a:srgbClr val="A9A6BD"/>
+                </a:solidFill>
+              </a:rPr>
+              <a:t>Totales, deudas, ventas del día y qué falta.</a:t>
+            </a:r>
+            <a:endParaRPr lang="en-US" sz="1200" dirty="0"/>
+          </a:p>
+        </p:txBody>
+      </p:sp>
+      <p:sp>
+        <p:nvSpPr>
+          <p:cNvPr id="19" name="Manos libres 3 círculo"/>
+          <p:cNvSpPr/>
+          <p:nvPr/>
+        </p:nvSpPr>
+        <p:spPr>
+          <a:xfrm>
+            <a:off x="3840480" y="2971800"/>
+            <a:ext cx="566928" cy="566928"/>
+          </a:xfrm>
+          <a:prstGeom prst="ellipse">
+            <a:avLst/>
+          </a:prstGeom>
+          <a:solidFill>
+            <a:srgbClr val="7C3AED"/>
+          </a:solidFill>
+          <a:ln w="12700">
+            <a:solidFill>
+              <a:srgbClr val="7C3AED"/>
+            </a:solidFill>
+            <a:prstDash val="solid"/>
+          </a:ln>
+        </p:spPr>
+      </p:sp>
+      <p:pic>
+        <p:nvPicPr>
+          <p:cNvPr id="20" name="Manos libres 3 ícono" descr="preencoded.png">    </p:cNvPr>
+          <p:cNvPicPr>
+            <a:picLocks noChangeAspect="1"/>
+          </p:cNvPicPr>
+          <p:nvPr/>
+        </p:nvPicPr>
+        <p:blipFill>
+          <a:blip r:embed="rId4"/>
+          <a:stretch>
+            <a:fillRect/>
+          </a:stretch>
+        </p:blipFill>
+        <p:spPr>
+          <a:xfrm>
+            <a:off x="3976543" y="3107863"/>
+            <a:ext cx="294803" cy="294803"/>
+          </a:xfrm>
+          <a:prstGeom prst="rect">
+            <a:avLst/>
+          </a:prstGeom>
+        </p:spPr>
+      </p:pic>
+      <p:sp>
+        <p:nvSpPr>
+          <p:cNvPr id="21" name="Manos libres título 3"/>
+          <p:cNvSpPr txBox="1"/>
+          <p:nvPr/>
+        </p:nvSpPr>
+        <p:spPr>
+          <a:xfrm>
+            <a:off x="3840480" y="3657600"/>
+            <a:ext cx="2240280" cy="292608"/>
+          </a:xfrm>
+          <a:prstGeom prst="rect">
+            <a:avLst/>
+          </a:prstGeom>
+          <a:noFill/>
+          <a:ln/>
+        </p:spPr>
+        <p:txBody>
+          <a:bodyPr wrap="square" lIns="0" tIns="0" rIns="0" bIns="0" rtlCol="0" anchor="ctr"/>
+          <a:lstStyle/>
+          <a:p>
+            <a:pPr indent="0" marL="0">
+              <a:buNone/>
+            </a:pPr>
+            <a:r>
+              <a:rPr lang="en-US" sz="1500" b="1" dirty="0">
+                <a:solidFill>
+                  <a:srgbClr val="FFFFFF"/>
+                </a:solidFill>
+                <a:latin typeface="Arial" pitchFamily="34" charset="0"/>
+                <a:ea typeface="Arial" pitchFamily="34" charset="-122"/>
+                <a:cs typeface="Arial" pitchFamily="34" charset="-120"/>
+              </a:rPr>
+              <a:t>Te avisa solo</a:t>
+            </a:r>
+            <a:endParaRPr lang="en-US" sz="1500" dirty="0"/>
+          </a:p>
+        </p:txBody>
+      </p:sp>
+      <p:sp>
+        <p:nvSpPr>
+          <p:cNvPr id="22" name="Manos libres texto 3"/>
+          <p:cNvSpPr txBox="1"/>
+          <p:nvPr/>
+        </p:nvSpPr>
+        <p:spPr>
+          <a:xfrm>
+            <a:off x="3840480" y="3959352"/>
+            <a:ext cx="2240280" cy="548640"/>
+          </a:xfrm>
+          <a:prstGeom prst="rect">
+            <a:avLst/>
+          </a:prstGeom>
+          <a:noFill/>
+          <a:ln/>
+        </p:spPr>
+        <p:txBody>
+          <a:bodyPr wrap="square" lIns="0" tIns="0" rIns="0" bIns="0" rtlCol="0" anchor="t"/>
+          <a:lstStyle/>
+          <a:p>
+            <a:pPr indent="0" marL="0">
+              <a:buNone/>
+            </a:pPr>
+            <a:r>
+              <a:rPr lang="en-US" sz="1200" dirty="0">
+                <a:solidFill>
+                  <a:srgbClr val="A9A6BD"/>
+                </a:solidFill>
+              </a:rPr>
+              <a:t>«Se están acabando las Águila», «la mesa 2 pidió».</a:t>
+            </a:r>
+            <a:endParaRPr lang="en-US" sz="1200" dirty="0"/>
+          </a:p>
+        </p:txBody>
+      </p:sp>
+      <p:sp>
+        <p:nvSpPr>
+          <p:cNvPr id="23" name="Manos libres 4 círculo"/>
+          <p:cNvSpPr/>
+          <p:nvPr/>
+        </p:nvSpPr>
+        <p:spPr>
+          <a:xfrm>
+            <a:off x="6263640" y="2971800"/>
+            <a:ext cx="566928" cy="566928"/>
+          </a:xfrm>
+          <a:prstGeom prst="ellipse">
+            <a:avLst/>
+          </a:prstGeom>
+          <a:solidFill>
+            <a:srgbClr val="7C3AED"/>
+          </a:solidFill>
+          <a:ln w="12700">
+            <a:solidFill>
+              <a:srgbClr val="7C3AED"/>
+            </a:solidFill>
+            <a:prstDash val="solid"/>
+          </a:ln>
+        </p:spPr>
+      </p:sp>
+      <p:pic>
+        <p:nvPicPr>
+          <p:cNvPr id="24" name="Manos libres 4 ícono" descr="preencoded.png">    </p:cNvPr>
+          <p:cNvPicPr>
+            <a:picLocks noChangeAspect="1"/>
+          </p:cNvPicPr>
+          <p:nvPr/>
+        </p:nvPicPr>
+        <p:blipFill>
+          <a:blip r:embed="rId5"/>
+          <a:stretch>
+            <a:fillRect/>
+          </a:stretch>
+        </p:blipFill>
+        <p:spPr>
+          <a:xfrm>
+            <a:off x="6399703" y="3107863"/>
+            <a:ext cx="294803" cy="294803"/>
+          </a:xfrm>
+          <a:prstGeom prst="rect">
+            <a:avLst/>
+          </a:prstGeom>
+        </p:spPr>
+      </p:pic>
+      <p:sp>
+        <p:nvSpPr>
+          <p:cNvPr id="25" name="Manos libres título 4"/>
+          <p:cNvSpPr txBox="1"/>
+          <p:nvPr/>
+        </p:nvSpPr>
+        <p:spPr>
+          <a:xfrm>
+            <a:off x="6263640" y="3657600"/>
+            <a:ext cx="2240280" cy="292608"/>
+          </a:xfrm>
+          <a:prstGeom prst="rect">
+            <a:avLst/>
+          </a:prstGeom>
+          <a:noFill/>
+          <a:ln/>
+        </p:spPr>
+        <p:txBody>
+          <a:bodyPr wrap="square" lIns="0" tIns="0" rIns="0" bIns="0" rtlCol="0" anchor="ctr"/>
+          <a:lstStyle/>
+          <a:p>
+            <a:pPr indent="0" marL="0">
+              <a:buNone/>
+            </a:pPr>
+            <a:r>
+              <a:rPr lang="en-US" sz="1500" b="1" dirty="0">
+                <a:solidFill>
+                  <a:srgbClr val="FFFFFF"/>
+                </a:solidFill>
+                <a:latin typeface="Arial" pitchFamily="34" charset="0"/>
+                <a:ea typeface="Arial" pitchFamily="34" charset="-122"/>
+                <a:cs typeface="Arial" pitchFamily="34" charset="-120"/>
+              </a:rPr>
+              <a:t>Parlante en la barra</a:t>
+            </a:r>
+            <a:endParaRPr lang="en-US" sz="1500" dirty="0"/>
+          </a:p>
+        </p:txBody>
+      </p:sp>
+      <p:sp>
+        <p:nvSpPr>
+          <p:cNvPr id="26" name="Manos libres texto 4"/>
+          <p:cNvSpPr txBox="1"/>
+          <p:nvPr/>
+        </p:nvSpPr>
+        <p:spPr>
+          <a:xfrm>
+            <a:off x="6263640" y="3959352"/>
+            <a:ext cx="2240280" cy="548640"/>
+          </a:xfrm>
+          <a:prstGeom prst="rect">
+            <a:avLst/>
+          </a:prstGeom>
+          <a:noFill/>
+          <a:ln/>
+        </p:spPr>
+        <p:txBody>
+          <a:bodyPr wrap="square" lIns="0" tIns="0" rIns="0" bIns="0" rtlCol="0" anchor="t"/>
+          <a:lstStyle/>
+          <a:p>
+            <a:pPr indent="0" marL="0">
+              <a:buNone/>
+            </a:pPr>
+            <a:r>
+              <a:rPr lang="en-US" sz="1200" dirty="0">
+                <a:solidFill>
+                  <a:srgbClr val="A9A6BD"/>
+                </a:solidFill>
+              </a:rPr>
+              <a:t>Un equipo Vento o el celular que ya tienes.</a:t>
+            </a:r>
+            <a:endParaRPr lang="en-US" sz="1200" dirty="0"/>
+          </a:p>
+        </p:txBody>
+      </p:sp>
+      <p:sp>
+        <p:nvSpPr>
+          <p:cNvPr id="25" name="Slide Number Placeholder 0"/>
+          <p:cNvSpPr>
+            <a:spLocks noGrp="1"/>
+          </p:cNvSpPr>
+          <p:nvPr>
+            <p:ph type="sldNum" sz="quarter" idx="4294967295"/>
+          </p:nvPr>
+        </p:nvSpPr>
+        <p:spPr>
+          <a:xfrm>
+            <a:off x="8412480" y="4754880"/>
+            <a:ext cx="457200" cy="274320"/>
+          </a:xfrm>
+          <a:prstGeom prst="rect">
+            <a:avLst/>
+          </a:prstGeom>
+          <a:extLst>
+            <a:ext uri="{C572A759-6A51-4108-AA02-DFA0A04FC94B}">
+              <ma14:wrappingTextBoxFlag xmlns:ma14="http://schemas.microsoft.com/office/mac/drawingml/2011/main" val="0"/>
+            </a:ext>
+          </a:extLst>
+        </p:spPr>
+        <p:txBody>
+          <a:bodyPr/>
+          <a:lstStyle>
+            <a:lvl1pPr>
+              <a:defRPr sz="1000">
+                <a:solidFill>
+                  <a:srgbClr val="9A97AD"/>
+                </a:solidFill>
+              </a:defRPr>
+            </a:lvl1pPr>
+          </a:lstStyle>
+          <a:p>
+            <a:pPr algn="r"/>
+            <a:fld id="{F7021451-1387-4CA6-816F-3879F97B5CBC}" type="slidenum">
+              <a:rPr b="0" lang="en-US"/>
+              <a:t>19</a:t>
+            </a:fld>
+            <a:endParaRPr lang="en-US"/>
+          </a:p>
+        </p:txBody>
+      </p:sp>
     </p:spTree>
   </p:cSld>
   <p:clrMapOvr>
@@ -12881,6 +13878,3493 @@
           </a:p>
         </p:txBody>
       </p:sp>
+    </p:spTree>
+  </p:cSld>
+  <p:clrMapOvr>
+    <a:masterClrMapping/>
+  </p:clrMapOvr>
+</p:sld>
+</file>
+
+<file path=ppt/slides/slide20.xml><?xml version="1.0" encoding="utf-8"?>
+<p:sld xmlns:a="http://schemas.openxmlformats.org/drawingml/2006/main" xmlns:r="http://schemas.openxmlformats.org/officeDocument/2006/relationships" xmlns:p="http://schemas.openxmlformats.org/presentationml/2006/main">
+  <p:cSld name="Slide 20">
+    <p:spTree>
+      <p:nvGrpSpPr>
+        <p:cNvPr id="1" name=""/>
+        <p:cNvGrpSpPr/>
+        <p:nvPr/>
+      </p:nvGrpSpPr>
+      <p:grpSpPr>
+        <a:xfrm>
+          <a:off x="0" y="0"/>
+          <a:ext cx="0" cy="0"/>
+          <a:chOff x="0" y="0"/>
+          <a:chExt cx="0" cy="0"/>
+        </a:xfrm>
+      </p:grpSpPr>
+      <p:sp>
+        <p:nvSpPr>
+          <p:cNvPr id="2" name="Text 0"/>
+          <p:cNvSpPr/>
+          <p:nvPr>
+            <p:ph idx="100" type="title" hasCustomPrompt="1"/>
+          </p:nvPr>
+        </p:nvSpPr>
+        <p:spPr>
+          <a:xfrm>
+            <a:off x="548640" y="320040"/>
+            <a:ext cx="8046720" cy="685800"/>
+          </a:xfrm>
+          <a:prstGeom prst="rect">
+            <a:avLst/>
+          </a:prstGeom>
+          <a:noFill/>
+          <a:ln/>
+        </p:spPr>
+        <p:txBody>
+          <a:bodyPr wrap="square" lIns="0" tIns="0" rIns="0" bIns="0" rtlCol="0" anchor="ctr"/>
+          <a:lstStyle/>
+          <a:p>
+            <a:pPr indent="0" marL="0">
+              <a:buNone/>
+            </a:pPr>
+            <a:r>
+              <a:rPr lang="en-US" sz="3000" b="1" dirty="0">
+                <a:solidFill>
+                  <a:schemeClr val="bg1"/>
+                </a:solidFill>
+              </a:rPr>
+              <a:t>Modo fácil, para todos</a:t>
+            </a:r>
+            <a:endParaRPr lang="en-US" sz="3000" dirty="0"/>
+          </a:p>
+        </p:txBody>
+      </p:sp>
+      <p:sp>
+        <p:nvSpPr>
+          <p:cNvPr id="3" name="Etiqueta futuro fondo"/>
+          <p:cNvSpPr/>
+          <p:nvPr/>
+        </p:nvSpPr>
+        <p:spPr>
+          <a:xfrm>
+            <a:off x="6263640" y="457200"/>
+            <a:ext cx="2331720" cy="329184"/>
+          </a:xfrm>
+          <a:prstGeom prst="roundRect">
+            <a:avLst>
+              <a:gd name="adj" fmla="val 50000"/>
+            </a:avLst>
+          </a:prstGeom>
+          <a:solidFill>
+            <a:srgbClr val="2A1F4A"/>
+          </a:solidFill>
+          <a:ln w="12700">
+            <a:solidFill>
+              <a:srgbClr val="7C3AED"/>
+            </a:solidFill>
+            <a:prstDash val="solid"/>
+          </a:ln>
+        </p:spPr>
+      </p:sp>
+      <p:sp>
+        <p:nvSpPr>
+          <p:cNvPr id="4" name="Etiqueta futuro"/>
+          <p:cNvSpPr txBox="1"/>
+          <p:nvPr/>
+        </p:nvSpPr>
+        <p:spPr>
+          <a:xfrm>
+            <a:off x="6263640" y="457200"/>
+            <a:ext cx="2331720" cy="329184"/>
+          </a:xfrm>
+          <a:prstGeom prst="rect">
+            <a:avLst/>
+          </a:prstGeom>
+          <a:noFill/>
+          <a:ln/>
+        </p:spPr>
+        <p:txBody>
+          <a:bodyPr wrap="square" lIns="0" tIns="0" rIns="0" bIns="0" rtlCol="0" anchor="ctr"/>
+          <a:lstStyle/>
+          <a:p>
+            <a:pPr algn="ctr" indent="0" marL="0">
+              <a:buNone/>
+            </a:pPr>
+            <a:r>
+              <a:rPr lang="en-US" sz="900" b="1" dirty="0">
+                <a:solidFill>
+                  <a:srgbClr val="C4B5FD"/>
+                </a:solidFill>
+              </a:rPr>
+              <a:t>EN DESARROLLO · IDEA DE FUTURO</a:t>
+            </a:r>
+            <a:endParaRPr lang="en-US" sz="900" dirty="0"/>
+          </a:p>
+        </p:txBody>
+      </p:sp>
+      <p:sp>
+        <p:nvSpPr>
+          <p:cNvPr id="5" name="Modo fácil 1"/>
+          <p:cNvSpPr/>
+          <p:nvPr/>
+        </p:nvSpPr>
+        <p:spPr>
+          <a:xfrm>
+            <a:off x="548640" y="1188720"/>
+            <a:ext cx="2542032" cy="1508760"/>
+          </a:xfrm>
+          <a:prstGeom prst="roundRect">
+            <a:avLst>
+              <a:gd name="adj" fmla="val 7273"/>
+            </a:avLst>
+          </a:prstGeom>
+          <a:solidFill>
+            <a:srgbClr val="1C1A2B"/>
+          </a:solidFill>
+          <a:ln w="9525">
+            <a:solidFill>
+              <a:srgbClr val="2E2A44"/>
+            </a:solidFill>
+            <a:prstDash val="solid"/>
+          </a:ln>
+        </p:spPr>
+      </p:sp>
+      <p:sp>
+        <p:nvSpPr>
+          <p:cNvPr id="6" name="Modo fácil 1 círculo"/>
+          <p:cNvSpPr/>
+          <p:nvPr/>
+        </p:nvSpPr>
+        <p:spPr>
+          <a:xfrm>
+            <a:off x="749808" y="1389888"/>
+            <a:ext cx="530352" cy="530352"/>
+          </a:xfrm>
+          <a:prstGeom prst="ellipse">
+            <a:avLst/>
+          </a:prstGeom>
+          <a:solidFill>
+            <a:srgbClr val="34D399"/>
+          </a:solidFill>
+          <a:ln w="12700">
+            <a:solidFill>
+              <a:srgbClr val="34D399"/>
+            </a:solidFill>
+            <a:prstDash val="solid"/>
+          </a:ln>
+        </p:spPr>
+      </p:sp>
+      <p:pic>
+        <p:nvPicPr>
+          <p:cNvPr id="7" name="Modo fácil 1 ícono" descr="preencoded.png">    </p:cNvPr>
+          <p:cNvPicPr>
+            <a:picLocks noChangeAspect="1"/>
+          </p:cNvPicPr>
+          <p:nvPr/>
+        </p:nvPicPr>
+        <p:blipFill>
+          <a:blip r:embed="rId1"/>
+          <a:stretch>
+            <a:fillRect/>
+          </a:stretch>
+        </p:blipFill>
+        <p:spPr>
+          <a:xfrm>
+            <a:off x="877092" y="1517172"/>
+            <a:ext cx="275783" cy="275783"/>
+          </a:xfrm>
+          <a:prstGeom prst="rect">
+            <a:avLst/>
+          </a:prstGeom>
+        </p:spPr>
+      </p:pic>
+      <p:sp>
+        <p:nvSpPr>
+          <p:cNvPr id="8" name="Modo fácil título 1"/>
+          <p:cNvSpPr txBox="1"/>
+          <p:nvPr/>
+        </p:nvSpPr>
+        <p:spPr>
+          <a:xfrm>
+            <a:off x="749808" y="2011680"/>
+            <a:ext cx="2194560" cy="274320"/>
+          </a:xfrm>
+          <a:prstGeom prst="rect">
+            <a:avLst/>
+          </a:prstGeom>
+          <a:noFill/>
+          <a:ln/>
+        </p:spPr>
+        <p:txBody>
+          <a:bodyPr wrap="square" lIns="0" tIns="0" rIns="0" bIns="0" rtlCol="0" anchor="ctr"/>
+          <a:lstStyle/>
+          <a:p>
+            <a:pPr indent="0" marL="0">
+              <a:buNone/>
+            </a:pPr>
+            <a:r>
+              <a:rPr lang="en-US" sz="1400" b="1" dirty="0">
+                <a:solidFill>
+                  <a:srgbClr val="FFFFFF"/>
+                </a:solidFill>
+                <a:latin typeface="Arial" pitchFamily="34" charset="0"/>
+                <a:ea typeface="Arial" pitchFamily="34" charset="-122"/>
+                <a:cs typeface="Arial" pitchFamily="34" charset="-120"/>
+              </a:rPr>
+              <a:t>Letras y botones grandes</a:t>
+            </a:r>
+            <a:endParaRPr lang="en-US" sz="1400" dirty="0"/>
+          </a:p>
+        </p:txBody>
+      </p:sp>
+      <p:sp>
+        <p:nvSpPr>
+          <p:cNvPr id="9" name="Modo fácil texto 1"/>
+          <p:cNvSpPr txBox="1"/>
+          <p:nvPr/>
+        </p:nvSpPr>
+        <p:spPr>
+          <a:xfrm>
+            <a:off x="749808" y="2286000"/>
+            <a:ext cx="2194560" cy="384048"/>
+          </a:xfrm>
+          <a:prstGeom prst="rect">
+            <a:avLst/>
+          </a:prstGeom>
+          <a:noFill/>
+          <a:ln/>
+        </p:spPr>
+        <p:txBody>
+          <a:bodyPr wrap="square" lIns="0" tIns="0" rIns="0" bIns="0" rtlCol="0" anchor="t"/>
+          <a:lstStyle/>
+          <a:p>
+            <a:pPr indent="0" marL="0">
+              <a:buNone/>
+            </a:pPr>
+            <a:r>
+              <a:rPr lang="en-US" sz="1100" dirty="0">
+                <a:solidFill>
+                  <a:srgbClr val="A9A6BD"/>
+                </a:solidFill>
+              </a:rPr>
+              <a:t>Pocas opciones en pantalla, fáciles de ver y de tocar.</a:t>
+            </a:r>
+            <a:endParaRPr lang="en-US" sz="1100" dirty="0"/>
+          </a:p>
+        </p:txBody>
+      </p:sp>
+      <p:sp>
+        <p:nvSpPr>
+          <p:cNvPr id="10" name="Modo fácil 2"/>
+          <p:cNvSpPr/>
+          <p:nvPr/>
+        </p:nvSpPr>
+        <p:spPr>
+          <a:xfrm>
+            <a:off x="3264408" y="1188720"/>
+            <a:ext cx="2542032" cy="1508760"/>
+          </a:xfrm>
+          <a:prstGeom prst="roundRect">
+            <a:avLst>
+              <a:gd name="adj" fmla="val 7273"/>
+            </a:avLst>
+          </a:prstGeom>
+          <a:solidFill>
+            <a:srgbClr val="1C1A2B"/>
+          </a:solidFill>
+          <a:ln w="9525">
+            <a:solidFill>
+              <a:srgbClr val="2E2A44"/>
+            </a:solidFill>
+            <a:prstDash val="solid"/>
+          </a:ln>
+        </p:spPr>
+      </p:sp>
+      <p:sp>
+        <p:nvSpPr>
+          <p:cNvPr id="11" name="Modo fácil 2 círculo"/>
+          <p:cNvSpPr/>
+          <p:nvPr/>
+        </p:nvSpPr>
+        <p:spPr>
+          <a:xfrm>
+            <a:off x="3465576" y="1389888"/>
+            <a:ext cx="530352" cy="530352"/>
+          </a:xfrm>
+          <a:prstGeom prst="ellipse">
+            <a:avLst/>
+          </a:prstGeom>
+          <a:solidFill>
+            <a:srgbClr val="34D399"/>
+          </a:solidFill>
+          <a:ln w="12700">
+            <a:solidFill>
+              <a:srgbClr val="34D399"/>
+            </a:solidFill>
+            <a:prstDash val="solid"/>
+          </a:ln>
+        </p:spPr>
+      </p:sp>
+      <p:pic>
+        <p:nvPicPr>
+          <p:cNvPr id="12" name="Modo fácil 2 ícono" descr="preencoded.png">    </p:cNvPr>
+          <p:cNvPicPr>
+            <a:picLocks noChangeAspect="1"/>
+          </p:cNvPicPr>
+          <p:nvPr/>
+        </p:nvPicPr>
+        <p:blipFill>
+          <a:blip r:embed="rId2"/>
+          <a:stretch>
+            <a:fillRect/>
+          </a:stretch>
+        </p:blipFill>
+        <p:spPr>
+          <a:xfrm>
+            <a:off x="3592860" y="1517172"/>
+            <a:ext cx="275783" cy="275783"/>
+          </a:xfrm>
+          <a:prstGeom prst="rect">
+            <a:avLst/>
+          </a:prstGeom>
+        </p:spPr>
+      </p:pic>
+      <p:sp>
+        <p:nvSpPr>
+          <p:cNvPr id="13" name="Modo fácil título 2"/>
+          <p:cNvSpPr txBox="1"/>
+          <p:nvPr/>
+        </p:nvSpPr>
+        <p:spPr>
+          <a:xfrm>
+            <a:off x="3465576" y="2011680"/>
+            <a:ext cx="2194560" cy="274320"/>
+          </a:xfrm>
+          <a:prstGeom prst="rect">
+            <a:avLst/>
+          </a:prstGeom>
+          <a:noFill/>
+          <a:ln/>
+        </p:spPr>
+        <p:txBody>
+          <a:bodyPr wrap="square" lIns="0" tIns="0" rIns="0" bIns="0" rtlCol="0" anchor="ctr"/>
+          <a:lstStyle/>
+          <a:p>
+            <a:pPr indent="0" marL="0">
+              <a:buNone/>
+            </a:pPr>
+            <a:r>
+              <a:rPr lang="en-US" sz="1400" b="1" dirty="0">
+                <a:solidFill>
+                  <a:srgbClr val="FFFFFF"/>
+                </a:solidFill>
+                <a:latin typeface="Arial" pitchFamily="34" charset="0"/>
+                <a:ea typeface="Arial" pitchFamily="34" charset="-122"/>
+                <a:cs typeface="Arial" pitchFamily="34" charset="-120"/>
+              </a:rPr>
+              <a:t>Todo hablando</a:t>
+            </a:r>
+            <a:endParaRPr lang="en-US" sz="1400" dirty="0"/>
+          </a:p>
+        </p:txBody>
+      </p:sp>
+      <p:sp>
+        <p:nvSpPr>
+          <p:cNvPr id="14" name="Modo fácil texto 2"/>
+          <p:cNvSpPr txBox="1"/>
+          <p:nvPr/>
+        </p:nvSpPr>
+        <p:spPr>
+          <a:xfrm>
+            <a:off x="3465576" y="2286000"/>
+            <a:ext cx="2194560" cy="384048"/>
+          </a:xfrm>
+          <a:prstGeom prst="rect">
+            <a:avLst/>
+          </a:prstGeom>
+          <a:noFill/>
+          <a:ln/>
+        </p:spPr>
+        <p:txBody>
+          <a:bodyPr wrap="square" lIns="0" tIns="0" rIns="0" bIns="0" rtlCol="0" anchor="t"/>
+          <a:lstStyle/>
+          <a:p>
+            <a:pPr indent="0" marL="0">
+              <a:buNone/>
+            </a:pPr>
+            <a:r>
+              <a:rPr lang="en-US" sz="1100" dirty="0">
+                <a:solidFill>
+                  <a:srgbClr val="A9A6BD"/>
+                </a:solidFill>
+              </a:rPr>
+              <a:t>Sin menús: se pide, se cobra y se pregunta con la voz.</a:t>
+            </a:r>
+            <a:endParaRPr lang="en-US" sz="1100" dirty="0"/>
+          </a:p>
+        </p:txBody>
+      </p:sp>
+      <p:sp>
+        <p:nvSpPr>
+          <p:cNvPr id="15" name="Modo fácil 3"/>
+          <p:cNvSpPr/>
+          <p:nvPr/>
+        </p:nvSpPr>
+        <p:spPr>
+          <a:xfrm>
+            <a:off x="5980176" y="1188720"/>
+            <a:ext cx="2542032" cy="1508760"/>
+          </a:xfrm>
+          <a:prstGeom prst="roundRect">
+            <a:avLst>
+              <a:gd name="adj" fmla="val 7273"/>
+            </a:avLst>
+          </a:prstGeom>
+          <a:solidFill>
+            <a:srgbClr val="1C1A2B"/>
+          </a:solidFill>
+          <a:ln w="9525">
+            <a:solidFill>
+              <a:srgbClr val="2E2A44"/>
+            </a:solidFill>
+            <a:prstDash val="solid"/>
+          </a:ln>
+        </p:spPr>
+      </p:sp>
+      <p:sp>
+        <p:nvSpPr>
+          <p:cNvPr id="16" name="Modo fácil 3 círculo"/>
+          <p:cNvSpPr/>
+          <p:nvPr/>
+        </p:nvSpPr>
+        <p:spPr>
+          <a:xfrm>
+            <a:off x="6181344" y="1389888"/>
+            <a:ext cx="530352" cy="530352"/>
+          </a:xfrm>
+          <a:prstGeom prst="ellipse">
+            <a:avLst/>
+          </a:prstGeom>
+          <a:solidFill>
+            <a:srgbClr val="34D399"/>
+          </a:solidFill>
+          <a:ln w="12700">
+            <a:solidFill>
+              <a:srgbClr val="34D399"/>
+            </a:solidFill>
+            <a:prstDash val="solid"/>
+          </a:ln>
+        </p:spPr>
+      </p:sp>
+      <p:pic>
+        <p:nvPicPr>
+          <p:cNvPr id="17" name="Modo fácil 3 ícono" descr="preencoded.png">    </p:cNvPr>
+          <p:cNvPicPr>
+            <a:picLocks noChangeAspect="1"/>
+          </p:cNvPicPr>
+          <p:nvPr/>
+        </p:nvPicPr>
+        <p:blipFill>
+          <a:blip r:embed="rId3"/>
+          <a:stretch>
+            <a:fillRect/>
+          </a:stretch>
+        </p:blipFill>
+        <p:spPr>
+          <a:xfrm>
+            <a:off x="6308628" y="1517172"/>
+            <a:ext cx="275783" cy="275783"/>
+          </a:xfrm>
+          <a:prstGeom prst="rect">
+            <a:avLst/>
+          </a:prstGeom>
+        </p:spPr>
+      </p:pic>
+      <p:sp>
+        <p:nvSpPr>
+          <p:cNvPr id="18" name="Modo fácil título 3"/>
+          <p:cNvSpPr txBox="1"/>
+          <p:nvPr/>
+        </p:nvSpPr>
+        <p:spPr>
+          <a:xfrm>
+            <a:off x="6181344" y="2011680"/>
+            <a:ext cx="2194560" cy="274320"/>
+          </a:xfrm>
+          <a:prstGeom prst="rect">
+            <a:avLst/>
+          </a:prstGeom>
+          <a:noFill/>
+          <a:ln/>
+        </p:spPr>
+        <p:txBody>
+          <a:bodyPr wrap="square" lIns="0" tIns="0" rIns="0" bIns="0" rtlCol="0" anchor="ctr"/>
+          <a:lstStyle/>
+          <a:p>
+            <a:pPr indent="0" marL="0">
+              <a:buNone/>
+            </a:pPr>
+            <a:r>
+              <a:rPr lang="en-US" sz="1400" b="1" dirty="0">
+                <a:solidFill>
+                  <a:srgbClr val="FFFFFF"/>
+                </a:solidFill>
+                <a:latin typeface="Arial" pitchFamily="34" charset="0"/>
+                <a:ea typeface="Arial" pitchFamily="34" charset="-122"/>
+                <a:cs typeface="Arial" pitchFamily="34" charset="-120"/>
+              </a:rPr>
+              <a:t>Vento lee en voz alta</a:t>
+            </a:r>
+            <a:endParaRPr lang="en-US" sz="1400" dirty="0"/>
+          </a:p>
+        </p:txBody>
+      </p:sp>
+      <p:sp>
+        <p:nvSpPr>
+          <p:cNvPr id="19" name="Modo fácil texto 3"/>
+          <p:cNvSpPr txBox="1"/>
+          <p:nvPr/>
+        </p:nvSpPr>
+        <p:spPr>
+          <a:xfrm>
+            <a:off x="6181344" y="2286000"/>
+            <a:ext cx="2194560" cy="384048"/>
+          </a:xfrm>
+          <a:prstGeom prst="rect">
+            <a:avLst/>
+          </a:prstGeom>
+          <a:noFill/>
+          <a:ln/>
+        </p:spPr>
+        <p:txBody>
+          <a:bodyPr wrap="square" lIns="0" tIns="0" rIns="0" bIns="0" rtlCol="0" anchor="t"/>
+          <a:lstStyle/>
+          <a:p>
+            <a:pPr indent="0" marL="0">
+              <a:buNone/>
+            </a:pPr>
+            <a:r>
+              <a:rPr lang="en-US" sz="1100" dirty="0">
+                <a:solidFill>
+                  <a:srgbClr val="A9A6BD"/>
+                </a:solidFill>
+              </a:rPr>
+              <a:t>Repite el pedido y el total antes de cobrar.</a:t>
+            </a:r>
+            <a:endParaRPr lang="en-US" sz="1100" dirty="0"/>
+          </a:p>
+        </p:txBody>
+      </p:sp>
+      <p:sp>
+        <p:nvSpPr>
+          <p:cNvPr id="20" name="Modo fácil 4"/>
+          <p:cNvSpPr/>
+          <p:nvPr/>
+        </p:nvSpPr>
+        <p:spPr>
+          <a:xfrm>
+            <a:off x="548640" y="2880360"/>
+            <a:ext cx="2542032" cy="1508760"/>
+          </a:xfrm>
+          <a:prstGeom prst="roundRect">
+            <a:avLst>
+              <a:gd name="adj" fmla="val 7273"/>
+            </a:avLst>
+          </a:prstGeom>
+          <a:solidFill>
+            <a:srgbClr val="1C1A2B"/>
+          </a:solidFill>
+          <a:ln w="9525">
+            <a:solidFill>
+              <a:srgbClr val="2E2A44"/>
+            </a:solidFill>
+            <a:prstDash val="solid"/>
+          </a:ln>
+        </p:spPr>
+      </p:sp>
+      <p:sp>
+        <p:nvSpPr>
+          <p:cNvPr id="21" name="Modo fácil 4 círculo"/>
+          <p:cNvSpPr/>
+          <p:nvPr/>
+        </p:nvSpPr>
+        <p:spPr>
+          <a:xfrm>
+            <a:off x="749808" y="3081528"/>
+            <a:ext cx="530352" cy="530352"/>
+          </a:xfrm>
+          <a:prstGeom prst="ellipse">
+            <a:avLst/>
+          </a:prstGeom>
+          <a:solidFill>
+            <a:srgbClr val="34D399"/>
+          </a:solidFill>
+          <a:ln w="12700">
+            <a:solidFill>
+              <a:srgbClr val="34D399"/>
+            </a:solidFill>
+            <a:prstDash val="solid"/>
+          </a:ln>
+        </p:spPr>
+      </p:sp>
+      <p:pic>
+        <p:nvPicPr>
+          <p:cNvPr id="22" name="Modo fácil 4 ícono" descr="preencoded.png">    </p:cNvPr>
+          <p:cNvPicPr>
+            <a:picLocks noChangeAspect="1"/>
+          </p:cNvPicPr>
+          <p:nvPr/>
+        </p:nvPicPr>
+        <p:blipFill>
+          <a:blip r:embed="rId4"/>
+          <a:stretch>
+            <a:fillRect/>
+          </a:stretch>
+        </p:blipFill>
+        <p:spPr>
+          <a:xfrm>
+            <a:off x="877092" y="3208812"/>
+            <a:ext cx="275783" cy="275783"/>
+          </a:xfrm>
+          <a:prstGeom prst="rect">
+            <a:avLst/>
+          </a:prstGeom>
+        </p:spPr>
+      </p:pic>
+      <p:sp>
+        <p:nvSpPr>
+          <p:cNvPr id="23" name="Modo fácil título 4"/>
+          <p:cNvSpPr txBox="1"/>
+          <p:nvPr/>
+        </p:nvSpPr>
+        <p:spPr>
+          <a:xfrm>
+            <a:off x="749808" y="3703320"/>
+            <a:ext cx="2194560" cy="274320"/>
+          </a:xfrm>
+          <a:prstGeom prst="rect">
+            <a:avLst/>
+          </a:prstGeom>
+          <a:noFill/>
+          <a:ln/>
+        </p:spPr>
+        <p:txBody>
+          <a:bodyPr wrap="square" lIns="0" tIns="0" rIns="0" bIns="0" rtlCol="0" anchor="ctr"/>
+          <a:lstStyle/>
+          <a:p>
+            <a:pPr indent="0" marL="0">
+              <a:buNone/>
+            </a:pPr>
+            <a:r>
+              <a:rPr lang="en-US" sz="1400" b="1" dirty="0">
+                <a:solidFill>
+                  <a:srgbClr val="FFFFFF"/>
+                </a:solidFill>
+                <a:latin typeface="Arial" pitchFamily="34" charset="0"/>
+                <a:ea typeface="Arial" pitchFamily="34" charset="-122"/>
+                <a:cs typeface="Arial" pitchFamily="34" charset="-120"/>
+              </a:rPr>
+              <a:t>Paso a paso</a:t>
+            </a:r>
+            <a:endParaRPr lang="en-US" sz="1400" dirty="0"/>
+          </a:p>
+        </p:txBody>
+      </p:sp>
+      <p:sp>
+        <p:nvSpPr>
+          <p:cNvPr id="24" name="Modo fácil texto 4"/>
+          <p:cNvSpPr txBox="1"/>
+          <p:nvPr/>
+        </p:nvSpPr>
+        <p:spPr>
+          <a:xfrm>
+            <a:off x="749808" y="3977640"/>
+            <a:ext cx="2194560" cy="384048"/>
+          </a:xfrm>
+          <a:prstGeom prst="rect">
+            <a:avLst/>
+          </a:prstGeom>
+          <a:noFill/>
+          <a:ln/>
+        </p:spPr>
+        <p:txBody>
+          <a:bodyPr wrap="square" lIns="0" tIns="0" rIns="0" bIns="0" rtlCol="0" anchor="t"/>
+          <a:lstStyle/>
+          <a:p>
+            <a:pPr indent="0" marL="0">
+              <a:buNone/>
+            </a:pPr>
+            <a:r>
+              <a:rPr lang="en-US" sz="1100" dirty="0">
+                <a:solidFill>
+                  <a:srgbClr val="A9A6BD"/>
+                </a:solidFill>
+              </a:rPr>
+              <a:t>Una sola pregunta a la vez, sin palabras técnicas.</a:t>
+            </a:r>
+            <a:endParaRPr lang="en-US" sz="1100" dirty="0"/>
+          </a:p>
+        </p:txBody>
+      </p:sp>
+      <p:sp>
+        <p:nvSpPr>
+          <p:cNvPr id="25" name="Modo fácil 5"/>
+          <p:cNvSpPr/>
+          <p:nvPr/>
+        </p:nvSpPr>
+        <p:spPr>
+          <a:xfrm>
+            <a:off x="3264408" y="2880360"/>
+            <a:ext cx="2542032" cy="1508760"/>
+          </a:xfrm>
+          <a:prstGeom prst="roundRect">
+            <a:avLst>
+              <a:gd name="adj" fmla="val 7273"/>
+            </a:avLst>
+          </a:prstGeom>
+          <a:solidFill>
+            <a:srgbClr val="1C1A2B"/>
+          </a:solidFill>
+          <a:ln w="9525">
+            <a:solidFill>
+              <a:srgbClr val="2E2A44"/>
+            </a:solidFill>
+            <a:prstDash val="solid"/>
+          </a:ln>
+        </p:spPr>
+      </p:sp>
+      <p:sp>
+        <p:nvSpPr>
+          <p:cNvPr id="26" name="Modo fácil 5 círculo"/>
+          <p:cNvSpPr/>
+          <p:nvPr/>
+        </p:nvSpPr>
+        <p:spPr>
+          <a:xfrm>
+            <a:off x="3465576" y="3081528"/>
+            <a:ext cx="530352" cy="530352"/>
+          </a:xfrm>
+          <a:prstGeom prst="ellipse">
+            <a:avLst/>
+          </a:prstGeom>
+          <a:solidFill>
+            <a:srgbClr val="34D399"/>
+          </a:solidFill>
+          <a:ln w="12700">
+            <a:solidFill>
+              <a:srgbClr val="34D399"/>
+            </a:solidFill>
+            <a:prstDash val="solid"/>
+          </a:ln>
+        </p:spPr>
+      </p:sp>
+      <p:pic>
+        <p:nvPicPr>
+          <p:cNvPr id="27" name="Modo fácil 5 ícono" descr="preencoded.png">    </p:cNvPr>
+          <p:cNvPicPr>
+            <a:picLocks noChangeAspect="1"/>
+          </p:cNvPicPr>
+          <p:nvPr/>
+        </p:nvPicPr>
+        <p:blipFill>
+          <a:blip r:embed="rId5"/>
+          <a:stretch>
+            <a:fillRect/>
+          </a:stretch>
+        </p:blipFill>
+        <p:spPr>
+          <a:xfrm>
+            <a:off x="3592860" y="3208812"/>
+            <a:ext cx="275783" cy="275783"/>
+          </a:xfrm>
+          <a:prstGeom prst="rect">
+            <a:avLst/>
+          </a:prstGeom>
+        </p:spPr>
+      </p:pic>
+      <p:sp>
+        <p:nvSpPr>
+          <p:cNvPr id="28" name="Modo fácil título 5"/>
+          <p:cNvSpPr txBox="1"/>
+          <p:nvPr/>
+        </p:nvSpPr>
+        <p:spPr>
+          <a:xfrm>
+            <a:off x="3465576" y="3703320"/>
+            <a:ext cx="2194560" cy="274320"/>
+          </a:xfrm>
+          <a:prstGeom prst="rect">
+            <a:avLst/>
+          </a:prstGeom>
+          <a:noFill/>
+          <a:ln/>
+        </p:spPr>
+        <p:txBody>
+          <a:bodyPr wrap="square" lIns="0" tIns="0" rIns="0" bIns="0" rtlCol="0" anchor="ctr"/>
+          <a:lstStyle/>
+          <a:p>
+            <a:pPr indent="0" marL="0">
+              <a:buNone/>
+            </a:pPr>
+            <a:r>
+              <a:rPr lang="en-US" sz="1400" b="1" dirty="0">
+                <a:solidFill>
+                  <a:srgbClr val="FFFFFF"/>
+                </a:solidFill>
+                <a:latin typeface="Arial" pitchFamily="34" charset="0"/>
+                <a:ea typeface="Arial" pitchFamily="34" charset="-122"/>
+                <a:cs typeface="Arial" pitchFamily="34" charset="-120"/>
+              </a:rPr>
+              <a:t>Un familiar ayuda</a:t>
+            </a:r>
+            <a:endParaRPr lang="en-US" sz="1400" dirty="0"/>
+          </a:p>
+        </p:txBody>
+      </p:sp>
+      <p:sp>
+        <p:nvSpPr>
+          <p:cNvPr id="29" name="Modo fácil texto 5"/>
+          <p:cNvSpPr txBox="1"/>
+          <p:nvPr/>
+        </p:nvSpPr>
+        <p:spPr>
+          <a:xfrm>
+            <a:off x="3465576" y="3977640"/>
+            <a:ext cx="2194560" cy="384048"/>
+          </a:xfrm>
+          <a:prstGeom prst="rect">
+            <a:avLst/>
+          </a:prstGeom>
+          <a:noFill/>
+          <a:ln/>
+        </p:spPr>
+        <p:txBody>
+          <a:bodyPr wrap="square" lIns="0" tIns="0" rIns="0" bIns="0" rtlCol="0" anchor="t"/>
+          <a:lstStyle/>
+          <a:p>
+            <a:pPr indent="0" marL="0">
+              <a:buNone/>
+            </a:pPr>
+            <a:r>
+              <a:rPr lang="en-US" sz="1100" dirty="0">
+                <a:solidFill>
+                  <a:srgbClr val="A9A6BD"/>
+                </a:solidFill>
+              </a:rPr>
+              <a:t>Hijos o nietos pueden apoyar a distancia desde su celular.</a:t>
+            </a:r>
+            <a:endParaRPr lang="en-US" sz="1100" dirty="0"/>
+          </a:p>
+        </p:txBody>
+      </p:sp>
+      <p:sp>
+        <p:nvSpPr>
+          <p:cNvPr id="30" name="Modo fácil 6"/>
+          <p:cNvSpPr/>
+          <p:nvPr/>
+        </p:nvSpPr>
+        <p:spPr>
+          <a:xfrm>
+            <a:off x="5980176" y="2880360"/>
+            <a:ext cx="2542032" cy="1508760"/>
+          </a:xfrm>
+          <a:prstGeom prst="roundRect">
+            <a:avLst>
+              <a:gd name="adj" fmla="val 7273"/>
+            </a:avLst>
+          </a:prstGeom>
+          <a:solidFill>
+            <a:srgbClr val="1C1A2B"/>
+          </a:solidFill>
+          <a:ln w="9525">
+            <a:solidFill>
+              <a:srgbClr val="2E2A44"/>
+            </a:solidFill>
+            <a:prstDash val="solid"/>
+          </a:ln>
+        </p:spPr>
+      </p:sp>
+      <p:sp>
+        <p:nvSpPr>
+          <p:cNvPr id="31" name="Modo fácil 6 círculo"/>
+          <p:cNvSpPr/>
+          <p:nvPr/>
+        </p:nvSpPr>
+        <p:spPr>
+          <a:xfrm>
+            <a:off x="6181344" y="3081528"/>
+            <a:ext cx="530352" cy="530352"/>
+          </a:xfrm>
+          <a:prstGeom prst="ellipse">
+            <a:avLst/>
+          </a:prstGeom>
+          <a:solidFill>
+            <a:srgbClr val="34D399"/>
+          </a:solidFill>
+          <a:ln w="12700">
+            <a:solidFill>
+              <a:srgbClr val="34D399"/>
+            </a:solidFill>
+            <a:prstDash val="solid"/>
+          </a:ln>
+        </p:spPr>
+      </p:sp>
+      <p:pic>
+        <p:nvPicPr>
+          <p:cNvPr id="32" name="Modo fácil 6 ícono" descr="preencoded.png">    </p:cNvPr>
+          <p:cNvPicPr>
+            <a:picLocks noChangeAspect="1"/>
+          </p:cNvPicPr>
+          <p:nvPr/>
+        </p:nvPicPr>
+        <p:blipFill>
+          <a:blip r:embed="rId6"/>
+          <a:stretch>
+            <a:fillRect/>
+          </a:stretch>
+        </p:blipFill>
+        <p:spPr>
+          <a:xfrm>
+            <a:off x="6308628" y="3208812"/>
+            <a:ext cx="275783" cy="275783"/>
+          </a:xfrm>
+          <a:prstGeom prst="rect">
+            <a:avLst/>
+          </a:prstGeom>
+        </p:spPr>
+      </p:pic>
+      <p:sp>
+        <p:nvSpPr>
+          <p:cNvPr id="33" name="Modo fácil título 6"/>
+          <p:cNvSpPr txBox="1"/>
+          <p:nvPr/>
+        </p:nvSpPr>
+        <p:spPr>
+          <a:xfrm>
+            <a:off x="6181344" y="3703320"/>
+            <a:ext cx="2194560" cy="274320"/>
+          </a:xfrm>
+          <a:prstGeom prst="rect">
+            <a:avLst/>
+          </a:prstGeom>
+          <a:noFill/>
+          <a:ln/>
+        </p:spPr>
+        <p:txBody>
+          <a:bodyPr wrap="square" lIns="0" tIns="0" rIns="0" bIns="0" rtlCol="0" anchor="ctr"/>
+          <a:lstStyle/>
+          <a:p>
+            <a:pPr indent="0" marL="0">
+              <a:buNone/>
+            </a:pPr>
+            <a:r>
+              <a:rPr lang="en-US" sz="1400" b="1" dirty="0">
+                <a:solidFill>
+                  <a:srgbClr val="FFFFFF"/>
+                </a:solidFill>
+                <a:latin typeface="Arial" pitchFamily="34" charset="0"/>
+                <a:ea typeface="Arial" pitchFamily="34" charset="-122"/>
+                <a:cs typeface="Arial" pitchFamily="34" charset="-120"/>
+              </a:rPr>
+              <a:t>Sin miedo a dañarlo</a:t>
+            </a:r>
+            <a:endParaRPr lang="en-US" sz="1400" dirty="0"/>
+          </a:p>
+        </p:txBody>
+      </p:sp>
+      <p:sp>
+        <p:nvSpPr>
+          <p:cNvPr id="34" name="Modo fácil texto 6"/>
+          <p:cNvSpPr txBox="1"/>
+          <p:nvPr/>
+        </p:nvSpPr>
+        <p:spPr>
+          <a:xfrm>
+            <a:off x="6181344" y="3977640"/>
+            <a:ext cx="2194560" cy="384048"/>
+          </a:xfrm>
+          <a:prstGeom prst="rect">
+            <a:avLst/>
+          </a:prstGeom>
+          <a:noFill/>
+          <a:ln/>
+        </p:spPr>
+        <p:txBody>
+          <a:bodyPr wrap="square" lIns="0" tIns="0" rIns="0" bIns="0" rtlCol="0" anchor="t"/>
+          <a:lstStyle/>
+          <a:p>
+            <a:pPr indent="0" marL="0">
+              <a:buNone/>
+            </a:pPr>
+            <a:r>
+              <a:rPr lang="en-US" sz="1100" dirty="0">
+                <a:solidFill>
+                  <a:srgbClr val="A9A6BD"/>
+                </a:solidFill>
+              </a:rPr>
+              <a:t>Todo se puede deshacer y nada se borra por error.</a:t>
+            </a:r>
+            <a:endParaRPr lang="en-US" sz="1100" dirty="0"/>
+          </a:p>
+        </p:txBody>
+      </p:sp>
+      <p:sp>
+        <p:nvSpPr>
+          <p:cNvPr id="35" name="Nota modo fácil"/>
+          <p:cNvSpPr txBox="1"/>
+          <p:nvPr/>
+        </p:nvSpPr>
+        <p:spPr>
+          <a:xfrm>
+            <a:off x="548640" y="4572000"/>
+            <a:ext cx="7589520" cy="274320"/>
+          </a:xfrm>
+          <a:prstGeom prst="rect">
+            <a:avLst/>
+          </a:prstGeom>
+          <a:noFill/>
+          <a:ln/>
+        </p:spPr>
+        <p:txBody>
+          <a:bodyPr wrap="square" lIns="0" tIns="0" rIns="0" bIns="0" rtlCol="0" anchor="ctr"/>
+          <a:lstStyle/>
+          <a:p>
+            <a:pPr indent="0" marL="0">
+              <a:buNone/>
+            </a:pPr>
+            <a:r>
+              <a:rPr lang="en-US" sz="1200" dirty="0">
+                <a:solidFill>
+                  <a:srgbClr val="C4B5FD"/>
+                </a:solidFill>
+              </a:rPr>
+              <a:t>Pensado para dueños mayores, personas con poca experiencia en tecnología o con la vista cansada.</a:t>
+            </a:r>
+            <a:endParaRPr lang="en-US" sz="1200" dirty="0"/>
+          </a:p>
+        </p:txBody>
+      </p:sp>
+      <p:sp>
+        <p:nvSpPr>
+          <p:cNvPr id="25" name="Slide Number Placeholder 0"/>
+          <p:cNvSpPr>
+            <a:spLocks noGrp="1"/>
+          </p:cNvSpPr>
+          <p:nvPr>
+            <p:ph type="sldNum" sz="quarter" idx="4294967295"/>
+          </p:nvPr>
+        </p:nvSpPr>
+        <p:spPr>
+          <a:xfrm>
+            <a:off x="8412480" y="4754880"/>
+            <a:ext cx="457200" cy="274320"/>
+          </a:xfrm>
+          <a:prstGeom prst="rect">
+            <a:avLst/>
+          </a:prstGeom>
+          <a:extLst>
+            <a:ext uri="{C572A759-6A51-4108-AA02-DFA0A04FC94B}">
+              <ma14:wrappingTextBoxFlag xmlns:ma14="http://schemas.microsoft.com/office/mac/drawingml/2011/main" val="0"/>
+            </a:ext>
+          </a:extLst>
+        </p:spPr>
+        <p:txBody>
+          <a:bodyPr/>
+          <a:lstStyle>
+            <a:lvl1pPr>
+              <a:defRPr sz="1000">
+                <a:solidFill>
+                  <a:srgbClr val="9A97AD"/>
+                </a:solidFill>
+              </a:defRPr>
+            </a:lvl1pPr>
+          </a:lstStyle>
+          <a:p>
+            <a:pPr algn="r"/>
+            <a:fld id="{F7021451-1387-4CA6-816F-3879F97B5CBC}" type="slidenum">
+              <a:rPr b="0" lang="en-US"/>
+              <a:t>20</a:t>
+            </a:fld>
+            <a:endParaRPr lang="en-US"/>
+          </a:p>
+        </p:txBody>
+      </p:sp>
+    </p:spTree>
+  </p:cSld>
+  <p:clrMapOvr>
+    <a:masterClrMapping/>
+  </p:clrMapOvr>
+</p:sld>
+</file>
+
+<file path=ppt/slides/slide21.xml><?xml version="1.0" encoding="utf-8"?>
+<p:sld xmlns:a="http://schemas.openxmlformats.org/drawingml/2006/main" xmlns:r="http://schemas.openxmlformats.org/officeDocument/2006/relationships" xmlns:p="http://schemas.openxmlformats.org/presentationml/2006/main">
+  <p:cSld name="Slide 21">
+    <p:spTree>
+      <p:nvGrpSpPr>
+        <p:cNvPr id="1" name=""/>
+        <p:cNvGrpSpPr/>
+        <p:nvPr/>
+      </p:nvGrpSpPr>
+      <p:grpSpPr>
+        <a:xfrm>
+          <a:off x="0" y="0"/>
+          <a:ext cx="0" cy="0"/>
+          <a:chOff x="0" y="0"/>
+          <a:chExt cx="0" cy="0"/>
+        </a:xfrm>
+      </p:grpSpPr>
+      <p:sp>
+        <p:nvSpPr>
+          <p:cNvPr id="2" name="Text 0"/>
+          <p:cNvSpPr/>
+          <p:nvPr>
+            <p:ph idx="100" type="title" hasCustomPrompt="1"/>
+          </p:nvPr>
+        </p:nvSpPr>
+        <p:spPr>
+          <a:xfrm>
+            <a:off x="548640" y="320040"/>
+            <a:ext cx="8046720" cy="685800"/>
+          </a:xfrm>
+          <a:prstGeom prst="rect">
+            <a:avLst/>
+          </a:prstGeom>
+          <a:noFill/>
+          <a:ln/>
+        </p:spPr>
+        <p:txBody>
+          <a:bodyPr wrap="square" lIns="0" tIns="0" rIns="0" bIns="0" rtlCol="0" anchor="ctr"/>
+          <a:lstStyle/>
+          <a:p>
+            <a:pPr indent="0" marL="0">
+              <a:buNone/>
+            </a:pPr>
+            <a:r>
+              <a:rPr lang="en-US" sz="3000" b="1" dirty="0">
+                <a:solidFill>
+                  <a:schemeClr val="bg1"/>
+                </a:solidFill>
+              </a:rPr>
+              <a:t>Cobros directos, sin comisión</a:t>
+            </a:r>
+            <a:endParaRPr lang="en-US" sz="3000" dirty="0"/>
+          </a:p>
+        </p:txBody>
+      </p:sp>
+      <p:sp>
+        <p:nvSpPr>
+          <p:cNvPr id="3" name="Etiqueta futuro fondo"/>
+          <p:cNvSpPr/>
+          <p:nvPr/>
+        </p:nvSpPr>
+        <p:spPr>
+          <a:xfrm>
+            <a:off x="6263640" y="457200"/>
+            <a:ext cx="2331720" cy="329184"/>
+          </a:xfrm>
+          <a:prstGeom prst="roundRect">
+            <a:avLst>
+              <a:gd name="adj" fmla="val 50000"/>
+            </a:avLst>
+          </a:prstGeom>
+          <a:solidFill>
+            <a:srgbClr val="2A1F4A"/>
+          </a:solidFill>
+          <a:ln w="12700">
+            <a:solidFill>
+              <a:srgbClr val="7C3AED"/>
+            </a:solidFill>
+            <a:prstDash val="solid"/>
+          </a:ln>
+        </p:spPr>
+      </p:sp>
+      <p:sp>
+        <p:nvSpPr>
+          <p:cNvPr id="4" name="Etiqueta futuro"/>
+          <p:cNvSpPr txBox="1"/>
+          <p:nvPr/>
+        </p:nvSpPr>
+        <p:spPr>
+          <a:xfrm>
+            <a:off x="6263640" y="457200"/>
+            <a:ext cx="2331720" cy="329184"/>
+          </a:xfrm>
+          <a:prstGeom prst="rect">
+            <a:avLst/>
+          </a:prstGeom>
+          <a:noFill/>
+          <a:ln/>
+        </p:spPr>
+        <p:txBody>
+          <a:bodyPr wrap="square" lIns="0" tIns="0" rIns="0" bIns="0" rtlCol="0" anchor="ctr"/>
+          <a:lstStyle/>
+          <a:p>
+            <a:pPr algn="ctr" indent="0" marL="0">
+              <a:buNone/>
+            </a:pPr>
+            <a:r>
+              <a:rPr lang="en-US" sz="900" b="1" dirty="0">
+                <a:solidFill>
+                  <a:srgbClr val="C4B5FD"/>
+                </a:solidFill>
+              </a:rPr>
+              <a:t>EN DESARROLLO · IDEA DE FUTURO</a:t>
+            </a:r>
+            <a:endParaRPr lang="en-US" sz="900" dirty="0"/>
+          </a:p>
+        </p:txBody>
+      </p:sp>
+      <p:sp>
+        <p:nvSpPr>
+          <p:cNvPr id="5" name="Paso cobro 1"/>
+          <p:cNvSpPr/>
+          <p:nvPr/>
+        </p:nvSpPr>
+        <p:spPr>
+          <a:xfrm>
+            <a:off x="548640" y="1188720"/>
+            <a:ext cx="2377440" cy="1783080"/>
+          </a:xfrm>
+          <a:prstGeom prst="roundRect">
+            <a:avLst>
+              <a:gd name="adj" fmla="val 6154"/>
+            </a:avLst>
+          </a:prstGeom>
+          <a:solidFill>
+            <a:srgbClr val="1C1A2B"/>
+          </a:solidFill>
+          <a:ln w="9525">
+            <a:solidFill>
+              <a:srgbClr val="2E2A44"/>
+            </a:solidFill>
+            <a:prstDash val="solid"/>
+          </a:ln>
+        </p:spPr>
+      </p:sp>
+      <p:sp>
+        <p:nvSpPr>
+          <p:cNvPr id="6" name="Paso cobro 1 círculo"/>
+          <p:cNvSpPr/>
+          <p:nvPr/>
+        </p:nvSpPr>
+        <p:spPr>
+          <a:xfrm>
+            <a:off x="749808" y="1371600"/>
+            <a:ext cx="548640" cy="548640"/>
+          </a:xfrm>
+          <a:prstGeom prst="ellipse">
+            <a:avLst/>
+          </a:prstGeom>
+          <a:solidFill>
+            <a:srgbClr val="7C3AED"/>
+          </a:solidFill>
+          <a:ln w="12700">
+            <a:solidFill>
+              <a:srgbClr val="7C3AED"/>
+            </a:solidFill>
+            <a:prstDash val="solid"/>
+          </a:ln>
+        </p:spPr>
+      </p:sp>
+      <p:pic>
+        <p:nvPicPr>
+          <p:cNvPr id="7" name="Paso cobro 1 ícono" descr="preencoded.png">    </p:cNvPr>
+          <p:cNvPicPr>
+            <a:picLocks noChangeAspect="1"/>
+          </p:cNvPicPr>
+          <p:nvPr/>
+        </p:nvPicPr>
+        <p:blipFill>
+          <a:blip r:embed="rId1"/>
+          <a:stretch>
+            <a:fillRect/>
+          </a:stretch>
+        </p:blipFill>
+        <p:spPr>
+          <a:xfrm>
+            <a:off x="881482" y="1503274"/>
+            <a:ext cx="285293" cy="285293"/>
+          </a:xfrm>
+          <a:prstGeom prst="rect">
+            <a:avLst/>
+          </a:prstGeom>
+        </p:spPr>
+      </p:pic>
+      <p:sp>
+        <p:nvSpPr>
+          <p:cNvPr id="8" name="Paso cobro título 1"/>
+          <p:cNvSpPr txBox="1"/>
+          <p:nvPr/>
+        </p:nvSpPr>
+        <p:spPr>
+          <a:xfrm>
+            <a:off x="749808" y="2011680"/>
+            <a:ext cx="2057400" cy="292608"/>
+          </a:xfrm>
+          <a:prstGeom prst="rect">
+            <a:avLst/>
+          </a:prstGeom>
+          <a:noFill/>
+          <a:ln/>
+        </p:spPr>
+        <p:txBody>
+          <a:bodyPr wrap="square" lIns="0" tIns="0" rIns="0" bIns="0" rtlCol="0" anchor="ctr"/>
+          <a:lstStyle/>
+          <a:p>
+            <a:pPr indent="0" marL="0">
+              <a:buNone/>
+            </a:pPr>
+            <a:r>
+              <a:rPr lang="en-US" sz="1400" b="1" dirty="0">
+                <a:solidFill>
+                  <a:srgbClr val="FFFFFF"/>
+                </a:solidFill>
+                <a:latin typeface="Arial" pitchFamily="34" charset="0"/>
+                <a:ea typeface="Arial" pitchFamily="34" charset="-122"/>
+                <a:cs typeface="Arial" pitchFamily="34" charset="-120"/>
+              </a:rPr>
+              <a:t>1. Muestra el cobro</a:t>
+            </a:r>
+            <a:endParaRPr lang="en-US" sz="1400" dirty="0"/>
+          </a:p>
+        </p:txBody>
+      </p:sp>
+      <p:sp>
+        <p:nvSpPr>
+          <p:cNvPr id="9" name="Paso cobro texto 1"/>
+          <p:cNvSpPr txBox="1"/>
+          <p:nvPr/>
+        </p:nvSpPr>
+        <p:spPr>
+          <a:xfrm>
+            <a:off x="749808" y="2313432"/>
+            <a:ext cx="2057400" cy="594360"/>
+          </a:xfrm>
+          <a:prstGeom prst="rect">
+            <a:avLst/>
+          </a:prstGeom>
+          <a:noFill/>
+          <a:ln/>
+        </p:spPr>
+        <p:txBody>
+          <a:bodyPr wrap="square" lIns="0" tIns="0" rIns="0" bIns="0" rtlCol="0" anchor="t"/>
+          <a:lstStyle/>
+          <a:p>
+            <a:pPr indent="0" marL="0">
+              <a:buNone/>
+            </a:pPr>
+            <a:r>
+              <a:rPr lang="en-US" sz="1150" dirty="0">
+                <a:solidFill>
+                  <a:srgbClr val="A9A6BD"/>
+                </a:solidFill>
+              </a:rPr>
+              <a:t>QR o llave con el valor exacto de la cuenta.</a:t>
+            </a:r>
+            <a:endParaRPr lang="en-US" sz="1150" dirty="0"/>
+          </a:p>
+        </p:txBody>
+      </p:sp>
+      <p:pic>
+        <p:nvPicPr>
+          <p:cNvPr id="10" name="Flecha 1" descr="preencoded.png">    </p:cNvPr>
+          <p:cNvPicPr>
+            <a:picLocks noChangeAspect="1"/>
+          </p:cNvPicPr>
+          <p:nvPr/>
+        </p:nvPicPr>
+        <p:blipFill>
+          <a:blip r:embed="rId2"/>
+          <a:stretch>
+            <a:fillRect/>
+          </a:stretch>
+        </p:blipFill>
+        <p:spPr>
+          <a:xfrm>
+            <a:off x="2980944" y="1965960"/>
+            <a:ext cx="228600" cy="228600"/>
+          </a:xfrm>
+          <a:prstGeom prst="rect">
+            <a:avLst/>
+          </a:prstGeom>
+        </p:spPr>
+      </p:pic>
+      <p:sp>
+        <p:nvSpPr>
+          <p:cNvPr id="11" name="Paso cobro 2"/>
+          <p:cNvSpPr/>
+          <p:nvPr/>
+        </p:nvSpPr>
+        <p:spPr>
+          <a:xfrm>
+            <a:off x="3264408" y="1188720"/>
+            <a:ext cx="2377440" cy="1783080"/>
+          </a:xfrm>
+          <a:prstGeom prst="roundRect">
+            <a:avLst>
+              <a:gd name="adj" fmla="val 6154"/>
+            </a:avLst>
+          </a:prstGeom>
+          <a:solidFill>
+            <a:srgbClr val="1C1A2B"/>
+          </a:solidFill>
+          <a:ln w="9525">
+            <a:solidFill>
+              <a:srgbClr val="2E2A44"/>
+            </a:solidFill>
+            <a:prstDash val="solid"/>
+          </a:ln>
+        </p:spPr>
+      </p:sp>
+      <p:sp>
+        <p:nvSpPr>
+          <p:cNvPr id="12" name="Paso cobro 2 círculo"/>
+          <p:cNvSpPr/>
+          <p:nvPr/>
+        </p:nvSpPr>
+        <p:spPr>
+          <a:xfrm>
+            <a:off x="3465576" y="1371600"/>
+            <a:ext cx="548640" cy="548640"/>
+          </a:xfrm>
+          <a:prstGeom prst="ellipse">
+            <a:avLst/>
+          </a:prstGeom>
+          <a:solidFill>
+            <a:srgbClr val="7C3AED"/>
+          </a:solidFill>
+          <a:ln w="12700">
+            <a:solidFill>
+              <a:srgbClr val="7C3AED"/>
+            </a:solidFill>
+            <a:prstDash val="solid"/>
+          </a:ln>
+        </p:spPr>
+      </p:sp>
+      <p:pic>
+        <p:nvPicPr>
+          <p:cNvPr id="13" name="Paso cobro 2 ícono" descr="preencoded.png">    </p:cNvPr>
+          <p:cNvPicPr>
+            <a:picLocks noChangeAspect="1"/>
+          </p:cNvPicPr>
+          <p:nvPr/>
+        </p:nvPicPr>
+        <p:blipFill>
+          <a:blip r:embed="rId3"/>
+          <a:stretch>
+            <a:fillRect/>
+          </a:stretch>
+        </p:blipFill>
+        <p:spPr>
+          <a:xfrm>
+            <a:off x="3597250" y="1503274"/>
+            <a:ext cx="285293" cy="285293"/>
+          </a:xfrm>
+          <a:prstGeom prst="rect">
+            <a:avLst/>
+          </a:prstGeom>
+        </p:spPr>
+      </p:pic>
+      <p:sp>
+        <p:nvSpPr>
+          <p:cNvPr id="14" name="Paso cobro título 2"/>
+          <p:cNvSpPr txBox="1"/>
+          <p:nvPr/>
+        </p:nvSpPr>
+        <p:spPr>
+          <a:xfrm>
+            <a:off x="3465576" y="2011680"/>
+            <a:ext cx="2057400" cy="292608"/>
+          </a:xfrm>
+          <a:prstGeom prst="rect">
+            <a:avLst/>
+          </a:prstGeom>
+          <a:noFill/>
+          <a:ln/>
+        </p:spPr>
+        <p:txBody>
+          <a:bodyPr wrap="square" lIns="0" tIns="0" rIns="0" bIns="0" rtlCol="0" anchor="ctr"/>
+          <a:lstStyle/>
+          <a:p>
+            <a:pPr indent="0" marL="0">
+              <a:buNone/>
+            </a:pPr>
+            <a:r>
+              <a:rPr lang="en-US" sz="1400" b="1" dirty="0">
+                <a:solidFill>
+                  <a:srgbClr val="FFFFFF"/>
+                </a:solidFill>
+                <a:latin typeface="Arial" pitchFamily="34" charset="0"/>
+                <a:ea typeface="Arial" pitchFamily="34" charset="-122"/>
+                <a:cs typeface="Arial" pitchFamily="34" charset="-120"/>
+              </a:rPr>
+              <a:t>2. El cliente paga</a:t>
+            </a:r>
+            <a:endParaRPr lang="en-US" sz="1400" dirty="0"/>
+          </a:p>
+        </p:txBody>
+      </p:sp>
+      <p:sp>
+        <p:nvSpPr>
+          <p:cNvPr id="15" name="Paso cobro texto 2"/>
+          <p:cNvSpPr txBox="1"/>
+          <p:nvPr/>
+        </p:nvSpPr>
+        <p:spPr>
+          <a:xfrm>
+            <a:off x="3465576" y="2313432"/>
+            <a:ext cx="2057400" cy="594360"/>
+          </a:xfrm>
+          <a:prstGeom prst="rect">
+            <a:avLst/>
+          </a:prstGeom>
+          <a:noFill/>
+          <a:ln/>
+        </p:spPr>
+        <p:txBody>
+          <a:bodyPr wrap="square" lIns="0" tIns="0" rIns="0" bIns="0" rtlCol="0" anchor="t"/>
+          <a:lstStyle/>
+          <a:p>
+            <a:pPr indent="0" marL="0">
+              <a:buNone/>
+            </a:pPr>
+            <a:r>
+              <a:rPr lang="en-US" sz="1150" dirty="0">
+                <a:solidFill>
+                  <a:srgbClr val="A9A6BD"/>
+                </a:solidFill>
+              </a:rPr>
+              <a:t>Con Nequi, Daviplata o Bre-B, desde su app.</a:t>
+            </a:r>
+            <a:endParaRPr lang="en-US" sz="1150" dirty="0"/>
+          </a:p>
+        </p:txBody>
+      </p:sp>
+      <p:pic>
+        <p:nvPicPr>
+          <p:cNvPr id="16" name="Flecha 2" descr="preencoded.png">    </p:cNvPr>
+          <p:cNvPicPr>
+            <a:picLocks noChangeAspect="1"/>
+          </p:cNvPicPr>
+          <p:nvPr/>
+        </p:nvPicPr>
+        <p:blipFill>
+          <a:blip r:embed="rId4"/>
+          <a:stretch>
+            <a:fillRect/>
+          </a:stretch>
+        </p:blipFill>
+        <p:spPr>
+          <a:xfrm>
+            <a:off x="5696712" y="1965960"/>
+            <a:ext cx="228600" cy="228600"/>
+          </a:xfrm>
+          <a:prstGeom prst="rect">
+            <a:avLst/>
+          </a:prstGeom>
+        </p:spPr>
+      </p:pic>
+      <p:sp>
+        <p:nvSpPr>
+          <p:cNvPr id="17" name="Paso cobro 3"/>
+          <p:cNvSpPr/>
+          <p:nvPr/>
+        </p:nvSpPr>
+        <p:spPr>
+          <a:xfrm>
+            <a:off x="5980176" y="1188720"/>
+            <a:ext cx="2377440" cy="1783080"/>
+          </a:xfrm>
+          <a:prstGeom prst="roundRect">
+            <a:avLst>
+              <a:gd name="adj" fmla="val 6154"/>
+            </a:avLst>
+          </a:prstGeom>
+          <a:solidFill>
+            <a:srgbClr val="1C1A2B"/>
+          </a:solidFill>
+          <a:ln w="9525">
+            <a:solidFill>
+              <a:srgbClr val="2E2A44"/>
+            </a:solidFill>
+            <a:prstDash val="solid"/>
+          </a:ln>
+        </p:spPr>
+      </p:sp>
+      <p:sp>
+        <p:nvSpPr>
+          <p:cNvPr id="18" name="Paso cobro 3 círculo"/>
+          <p:cNvSpPr/>
+          <p:nvPr/>
+        </p:nvSpPr>
+        <p:spPr>
+          <a:xfrm>
+            <a:off x="6181344" y="1371600"/>
+            <a:ext cx="548640" cy="548640"/>
+          </a:xfrm>
+          <a:prstGeom prst="ellipse">
+            <a:avLst/>
+          </a:prstGeom>
+          <a:solidFill>
+            <a:srgbClr val="7C3AED"/>
+          </a:solidFill>
+          <a:ln w="12700">
+            <a:solidFill>
+              <a:srgbClr val="7C3AED"/>
+            </a:solidFill>
+            <a:prstDash val="solid"/>
+          </a:ln>
+        </p:spPr>
+      </p:sp>
+      <p:pic>
+        <p:nvPicPr>
+          <p:cNvPr id="19" name="Paso cobro 3 ícono" descr="preencoded.png">    </p:cNvPr>
+          <p:cNvPicPr>
+            <a:picLocks noChangeAspect="1"/>
+          </p:cNvPicPr>
+          <p:nvPr/>
+        </p:nvPicPr>
+        <p:blipFill>
+          <a:blip r:embed="rId5"/>
+          <a:stretch>
+            <a:fillRect/>
+          </a:stretch>
+        </p:blipFill>
+        <p:spPr>
+          <a:xfrm>
+            <a:off x="6313018" y="1503274"/>
+            <a:ext cx="285293" cy="285293"/>
+          </a:xfrm>
+          <a:prstGeom prst="rect">
+            <a:avLst/>
+          </a:prstGeom>
+        </p:spPr>
+      </p:pic>
+      <p:sp>
+        <p:nvSpPr>
+          <p:cNvPr id="20" name="Paso cobro título 3"/>
+          <p:cNvSpPr txBox="1"/>
+          <p:nvPr/>
+        </p:nvSpPr>
+        <p:spPr>
+          <a:xfrm>
+            <a:off x="6181344" y="2011680"/>
+            <a:ext cx="2057400" cy="292608"/>
+          </a:xfrm>
+          <a:prstGeom prst="rect">
+            <a:avLst/>
+          </a:prstGeom>
+          <a:noFill/>
+          <a:ln/>
+        </p:spPr>
+        <p:txBody>
+          <a:bodyPr wrap="square" lIns="0" tIns="0" rIns="0" bIns="0" rtlCol="0" anchor="ctr"/>
+          <a:lstStyle/>
+          <a:p>
+            <a:pPr indent="0" marL="0">
+              <a:buNone/>
+            </a:pPr>
+            <a:r>
+              <a:rPr lang="en-US" sz="1400" b="1" dirty="0">
+                <a:solidFill>
+                  <a:srgbClr val="FFFFFF"/>
+                </a:solidFill>
+                <a:latin typeface="Arial" pitchFamily="34" charset="0"/>
+                <a:ea typeface="Arial" pitchFamily="34" charset="-122"/>
+                <a:cs typeface="Arial" pitchFamily="34" charset="-120"/>
+              </a:rPr>
+              <a:t>3. Vento confirma solo</a:t>
+            </a:r>
+            <a:endParaRPr lang="en-US" sz="1400" dirty="0"/>
+          </a:p>
+        </p:txBody>
+      </p:sp>
+      <p:sp>
+        <p:nvSpPr>
+          <p:cNvPr id="21" name="Paso cobro texto 3"/>
+          <p:cNvSpPr txBox="1"/>
+          <p:nvPr/>
+        </p:nvSpPr>
+        <p:spPr>
+          <a:xfrm>
+            <a:off x="6181344" y="2313432"/>
+            <a:ext cx="2057400" cy="594360"/>
+          </a:xfrm>
+          <a:prstGeom prst="rect">
+            <a:avLst/>
+          </a:prstGeom>
+          <a:noFill/>
+          <a:ln/>
+        </p:spPr>
+        <p:txBody>
+          <a:bodyPr wrap="square" lIns="0" tIns="0" rIns="0" bIns="0" rtlCol="0" anchor="t"/>
+          <a:lstStyle/>
+          <a:p>
+            <a:pPr indent="0" marL="0">
+              <a:buNone/>
+            </a:pPr>
+            <a:r>
+              <a:rPr lang="en-US" sz="1150" dirty="0">
+                <a:solidFill>
+                  <a:srgbClr val="A9A6BD"/>
+                </a:solidFill>
+              </a:rPr>
+              <a:t>Lee el aviso del pago en el celular del negocio y cierra la cuenta.</a:t>
+            </a:r>
+            <a:endParaRPr lang="en-US" sz="1150" dirty="0"/>
+          </a:p>
+        </p:txBody>
+      </p:sp>
+      <p:sp>
+        <p:nvSpPr>
+          <p:cNvPr id="22" name="Ventaja 1"/>
+          <p:cNvSpPr/>
+          <p:nvPr/>
+        </p:nvSpPr>
+        <p:spPr>
+          <a:xfrm>
+            <a:off x="548640" y="3200400"/>
+            <a:ext cx="1874520" cy="1371600"/>
+          </a:xfrm>
+          <a:prstGeom prst="roundRect">
+            <a:avLst>
+              <a:gd name="adj" fmla="val 8000"/>
+            </a:avLst>
+          </a:prstGeom>
+          <a:solidFill>
+            <a:srgbClr val="13261F"/>
+          </a:solidFill>
+          <a:ln w="9525">
+            <a:solidFill>
+              <a:srgbClr val="2E2A44"/>
+            </a:solidFill>
+            <a:prstDash val="solid"/>
+          </a:ln>
+        </p:spPr>
+      </p:sp>
+      <p:sp>
+        <p:nvSpPr>
+          <p:cNvPr id="23" name="Ventaja cifra 1"/>
+          <p:cNvSpPr txBox="1"/>
+          <p:nvPr/>
+        </p:nvSpPr>
+        <p:spPr>
+          <a:xfrm>
+            <a:off x="713232" y="3310128"/>
+            <a:ext cx="1600200" cy="502920"/>
+          </a:xfrm>
+          <a:prstGeom prst="rect">
+            <a:avLst/>
+          </a:prstGeom>
+          <a:noFill/>
+          <a:ln/>
+        </p:spPr>
+        <p:txBody>
+          <a:bodyPr wrap="square" lIns="0" tIns="0" rIns="0" bIns="0" rtlCol="0" anchor="ctr"/>
+          <a:lstStyle/>
+          <a:p>
+            <a:pPr indent="0" marL="0">
+              <a:buNone/>
+            </a:pPr>
+            <a:r>
+              <a:rPr lang="en-US" sz="3000" b="1" dirty="0">
+                <a:solidFill>
+                  <a:srgbClr val="34D399"/>
+                </a:solidFill>
+                <a:latin typeface="Arial" pitchFamily="34" charset="0"/>
+                <a:ea typeface="Arial" pitchFamily="34" charset="-122"/>
+                <a:cs typeface="Arial" pitchFamily="34" charset="-120"/>
+              </a:rPr>
+              <a:t>0 %</a:t>
+            </a:r>
+            <a:endParaRPr lang="en-US" sz="3000" dirty="0"/>
+          </a:p>
+        </p:txBody>
+      </p:sp>
+      <p:sp>
+        <p:nvSpPr>
+          <p:cNvPr id="24" name="Ventaja texto 1"/>
+          <p:cNvSpPr txBox="1"/>
+          <p:nvPr/>
+        </p:nvSpPr>
+        <p:spPr>
+          <a:xfrm>
+            <a:off x="713232" y="3840480"/>
+            <a:ext cx="1600200" cy="658368"/>
+          </a:xfrm>
+          <a:prstGeom prst="rect">
+            <a:avLst/>
+          </a:prstGeom>
+          <a:noFill/>
+          <a:ln/>
+        </p:spPr>
+        <p:txBody>
+          <a:bodyPr wrap="square" lIns="0" tIns="0" rIns="0" bIns="0" rtlCol="0" anchor="t"/>
+          <a:lstStyle/>
+          <a:p>
+            <a:pPr indent="0" marL="0">
+              <a:buNone/>
+            </a:pPr>
+            <a:r>
+              <a:rPr lang="en-US" sz="1100" dirty="0">
+                <a:solidFill>
+                  <a:srgbClr val="F2F1F7"/>
+                </a:solidFill>
+              </a:rPr>
+              <a:t>de comisión de Vento por venta</a:t>
+            </a:r>
+            <a:endParaRPr lang="en-US" sz="1100" dirty="0"/>
+          </a:p>
+        </p:txBody>
+      </p:sp>
+      <p:sp>
+        <p:nvSpPr>
+          <p:cNvPr id="25" name="Ventaja 2"/>
+          <p:cNvSpPr/>
+          <p:nvPr/>
+        </p:nvSpPr>
+        <p:spPr>
+          <a:xfrm>
+            <a:off x="2578608" y="3200400"/>
+            <a:ext cx="1874520" cy="1371600"/>
+          </a:xfrm>
+          <a:prstGeom prst="roundRect">
+            <a:avLst>
+              <a:gd name="adj" fmla="val 8000"/>
+            </a:avLst>
+          </a:prstGeom>
+          <a:solidFill>
+            <a:srgbClr val="13261F"/>
+          </a:solidFill>
+          <a:ln w="9525">
+            <a:solidFill>
+              <a:srgbClr val="2E2A44"/>
+            </a:solidFill>
+            <a:prstDash val="solid"/>
+          </a:ln>
+        </p:spPr>
+      </p:sp>
+      <p:sp>
+        <p:nvSpPr>
+          <p:cNvPr id="26" name="Ventaja cifra 2"/>
+          <p:cNvSpPr txBox="1"/>
+          <p:nvPr/>
+        </p:nvSpPr>
+        <p:spPr>
+          <a:xfrm>
+            <a:off x="2743200" y="3310128"/>
+            <a:ext cx="1600200" cy="502920"/>
+          </a:xfrm>
+          <a:prstGeom prst="rect">
+            <a:avLst/>
+          </a:prstGeom>
+          <a:noFill/>
+          <a:ln/>
+        </p:spPr>
+        <p:txBody>
+          <a:bodyPr wrap="square" lIns="0" tIns="0" rIns="0" bIns="0" rtlCol="0" anchor="ctr"/>
+          <a:lstStyle/>
+          <a:p>
+            <a:pPr indent="0" marL="0">
+              <a:buNone/>
+            </a:pPr>
+            <a:r>
+              <a:rPr lang="en-US" sz="3000" b="1" dirty="0">
+                <a:solidFill>
+                  <a:srgbClr val="34D399"/>
+                </a:solidFill>
+                <a:latin typeface="Arial" pitchFamily="34" charset="0"/>
+                <a:ea typeface="Arial" pitchFamily="34" charset="-122"/>
+                <a:cs typeface="Arial" pitchFamily="34" charset="-120"/>
+              </a:rPr>
+              <a:t>$0</a:t>
+            </a:r>
+            <a:endParaRPr lang="en-US" sz="3000" dirty="0"/>
+          </a:p>
+        </p:txBody>
+      </p:sp>
+      <p:sp>
+        <p:nvSpPr>
+          <p:cNvPr id="27" name="Ventaja texto 2"/>
+          <p:cNvSpPr txBox="1"/>
+          <p:nvPr/>
+        </p:nvSpPr>
+        <p:spPr>
+          <a:xfrm>
+            <a:off x="2743200" y="3840480"/>
+            <a:ext cx="1600200" cy="658368"/>
+          </a:xfrm>
+          <a:prstGeom prst="rect">
+            <a:avLst/>
+          </a:prstGeom>
+          <a:noFill/>
+          <a:ln/>
+        </p:spPr>
+        <p:txBody>
+          <a:bodyPr wrap="square" lIns="0" tIns="0" rIns="0" bIns="0" rtlCol="0" anchor="t"/>
+          <a:lstStyle/>
+          <a:p>
+            <a:pPr indent="0" marL="0">
+              <a:buNone/>
+            </a:pPr>
+            <a:r>
+              <a:rPr lang="en-US" sz="1100" dirty="0">
+                <a:solidFill>
+                  <a:srgbClr val="F2F1F7"/>
+                </a:solidFill>
+              </a:rPr>
+              <a:t>por verificar cada pago</a:t>
+            </a:r>
+            <a:endParaRPr lang="en-US" sz="1100" dirty="0"/>
+          </a:p>
+        </p:txBody>
+      </p:sp>
+      <p:sp>
+        <p:nvSpPr>
+          <p:cNvPr id="28" name="Ventaja 3"/>
+          <p:cNvSpPr/>
+          <p:nvPr/>
+        </p:nvSpPr>
+        <p:spPr>
+          <a:xfrm>
+            <a:off x="4608576" y="3200400"/>
+            <a:ext cx="1874520" cy="1371600"/>
+          </a:xfrm>
+          <a:prstGeom prst="roundRect">
+            <a:avLst>
+              <a:gd name="adj" fmla="val 8000"/>
+            </a:avLst>
+          </a:prstGeom>
+          <a:solidFill>
+            <a:srgbClr val="13261F"/>
+          </a:solidFill>
+          <a:ln w="9525">
+            <a:solidFill>
+              <a:srgbClr val="2E2A44"/>
+            </a:solidFill>
+            <a:prstDash val="solid"/>
+          </a:ln>
+        </p:spPr>
+      </p:sp>
+      <p:sp>
+        <p:nvSpPr>
+          <p:cNvPr id="29" name="Ventaja cifra 3"/>
+          <p:cNvSpPr txBox="1"/>
+          <p:nvPr/>
+        </p:nvSpPr>
+        <p:spPr>
+          <a:xfrm>
+            <a:off x="4773168" y="3310128"/>
+            <a:ext cx="1600200" cy="502920"/>
+          </a:xfrm>
+          <a:prstGeom prst="rect">
+            <a:avLst/>
+          </a:prstGeom>
+          <a:noFill/>
+          <a:ln/>
+        </p:spPr>
+        <p:txBody>
+          <a:bodyPr wrap="square" lIns="0" tIns="0" rIns="0" bIns="0" rtlCol="0" anchor="ctr"/>
+          <a:lstStyle/>
+          <a:p>
+            <a:pPr indent="0" marL="0">
+              <a:buNone/>
+            </a:pPr>
+            <a:r>
+              <a:rPr lang="en-US" sz="2200" b="1" dirty="0">
+                <a:solidFill>
+                  <a:srgbClr val="34D399"/>
+                </a:solidFill>
+                <a:latin typeface="Arial" pitchFamily="34" charset="0"/>
+                <a:ea typeface="Arial" pitchFamily="34" charset="-122"/>
+                <a:cs typeface="Arial" pitchFamily="34" charset="-120"/>
+              </a:rPr>
+              <a:t>Directo</a:t>
+            </a:r>
+            <a:endParaRPr lang="en-US" sz="2200" dirty="0"/>
+          </a:p>
+        </p:txBody>
+      </p:sp>
+      <p:sp>
+        <p:nvSpPr>
+          <p:cNvPr id="30" name="Ventaja texto 3"/>
+          <p:cNvSpPr txBox="1"/>
+          <p:nvPr/>
+        </p:nvSpPr>
+        <p:spPr>
+          <a:xfrm>
+            <a:off x="4773168" y="3840480"/>
+            <a:ext cx="1600200" cy="658368"/>
+          </a:xfrm>
+          <a:prstGeom prst="rect">
+            <a:avLst/>
+          </a:prstGeom>
+          <a:noFill/>
+          <a:ln/>
+        </p:spPr>
+        <p:txBody>
+          <a:bodyPr wrap="square" lIns="0" tIns="0" rIns="0" bIns="0" rtlCol="0" anchor="t"/>
+          <a:lstStyle/>
+          <a:p>
+            <a:pPr indent="0" marL="0">
+              <a:buNone/>
+            </a:pPr>
+            <a:r>
+              <a:rPr lang="en-US" sz="1100" dirty="0">
+                <a:solidFill>
+                  <a:srgbClr val="F2F1F7"/>
+                </a:solidFill>
+              </a:rPr>
+              <a:t>el dinero llega a tu cuenta, sin intermediarios</a:t>
+            </a:r>
+            <a:endParaRPr lang="en-US" sz="1100" dirty="0"/>
+          </a:p>
+        </p:txBody>
+      </p:sp>
+      <p:sp>
+        <p:nvSpPr>
+          <p:cNvPr id="31" name="Ventaja 4"/>
+          <p:cNvSpPr/>
+          <p:nvPr/>
+        </p:nvSpPr>
+        <p:spPr>
+          <a:xfrm>
+            <a:off x="6638544" y="3200400"/>
+            <a:ext cx="1874520" cy="1371600"/>
+          </a:xfrm>
+          <a:prstGeom prst="roundRect">
+            <a:avLst>
+              <a:gd name="adj" fmla="val 8000"/>
+            </a:avLst>
+          </a:prstGeom>
+          <a:solidFill>
+            <a:srgbClr val="13261F"/>
+          </a:solidFill>
+          <a:ln w="9525">
+            <a:solidFill>
+              <a:srgbClr val="2E2A44"/>
+            </a:solidFill>
+            <a:prstDash val="solid"/>
+          </a:ln>
+        </p:spPr>
+      </p:sp>
+      <p:sp>
+        <p:nvSpPr>
+          <p:cNvPr id="32" name="Ventaja cifra 4"/>
+          <p:cNvSpPr txBox="1"/>
+          <p:nvPr/>
+        </p:nvSpPr>
+        <p:spPr>
+          <a:xfrm>
+            <a:off x="6803136" y="3310128"/>
+            <a:ext cx="1600200" cy="502920"/>
+          </a:xfrm>
+          <a:prstGeom prst="rect">
+            <a:avLst/>
+          </a:prstGeom>
+          <a:noFill/>
+          <a:ln/>
+        </p:spPr>
+        <p:txBody>
+          <a:bodyPr wrap="square" lIns="0" tIns="0" rIns="0" bIns="0" rtlCol="0" anchor="ctr"/>
+          <a:lstStyle/>
+          <a:p>
+            <a:pPr indent="0" marL="0">
+              <a:buNone/>
+            </a:pPr>
+            <a:r>
+              <a:rPr lang="en-US" sz="2200" b="1" dirty="0">
+                <a:solidFill>
+                  <a:srgbClr val="34D399"/>
+                </a:solidFill>
+                <a:latin typeface="Arial" pitchFamily="34" charset="0"/>
+                <a:ea typeface="Arial" pitchFamily="34" charset="-122"/>
+                <a:cs typeface="Arial" pitchFamily="34" charset="-120"/>
+              </a:rPr>
+              <a:t>Cuadre</a:t>
+            </a:r>
+            <a:endParaRPr lang="en-US" sz="2200" dirty="0"/>
+          </a:p>
+        </p:txBody>
+      </p:sp>
+      <p:sp>
+        <p:nvSpPr>
+          <p:cNvPr id="33" name="Ventaja texto 4"/>
+          <p:cNvSpPr txBox="1"/>
+          <p:nvPr/>
+        </p:nvSpPr>
+        <p:spPr>
+          <a:xfrm>
+            <a:off x="6803136" y="3840480"/>
+            <a:ext cx="1600200" cy="658368"/>
+          </a:xfrm>
+          <a:prstGeom prst="rect">
+            <a:avLst/>
+          </a:prstGeom>
+          <a:noFill/>
+          <a:ln/>
+        </p:spPr>
+        <p:txBody>
+          <a:bodyPr wrap="square" lIns="0" tIns="0" rIns="0" bIns="0" rtlCol="0" anchor="t"/>
+          <a:lstStyle/>
+          <a:p>
+            <a:pPr indent="0" marL="0">
+              <a:buNone/>
+            </a:pPr>
+            <a:r>
+              <a:rPr lang="en-US" sz="1100" dirty="0">
+                <a:solidFill>
+                  <a:srgbClr val="F2F1F7"/>
+                </a:solidFill>
+              </a:rPr>
+              <a:t>del día automático y alerta de comprobantes falsos</a:t>
+            </a:r>
+            <a:endParaRPr lang="en-US" sz="1100" dirty="0"/>
+          </a:p>
+        </p:txBody>
+      </p:sp>
+      <p:sp>
+        <p:nvSpPr>
+          <p:cNvPr id="25" name="Slide Number Placeholder 0"/>
+          <p:cNvSpPr>
+            <a:spLocks noGrp="1"/>
+          </p:cNvSpPr>
+          <p:nvPr>
+            <p:ph type="sldNum" sz="quarter" idx="4294967295"/>
+          </p:nvPr>
+        </p:nvSpPr>
+        <p:spPr>
+          <a:xfrm>
+            <a:off x="8412480" y="4754880"/>
+            <a:ext cx="457200" cy="274320"/>
+          </a:xfrm>
+          <a:prstGeom prst="rect">
+            <a:avLst/>
+          </a:prstGeom>
+          <a:extLst>
+            <a:ext uri="{C572A759-6A51-4108-AA02-DFA0A04FC94B}">
+              <ma14:wrappingTextBoxFlag xmlns:ma14="http://schemas.microsoft.com/office/mac/drawingml/2011/main" val="0"/>
+            </a:ext>
+          </a:extLst>
+        </p:spPr>
+        <p:txBody>
+          <a:bodyPr/>
+          <a:lstStyle>
+            <a:lvl1pPr>
+              <a:defRPr sz="1000">
+                <a:solidFill>
+                  <a:srgbClr val="9A97AD"/>
+                </a:solidFill>
+              </a:defRPr>
+            </a:lvl1pPr>
+          </a:lstStyle>
+          <a:p>
+            <a:pPr algn="r"/>
+            <a:fld id="{F7021451-1387-4CA6-816F-3879F97B5CBC}" type="slidenum">
+              <a:rPr b="0" lang="en-US"/>
+              <a:t>21</a:t>
+            </a:fld>
+            <a:endParaRPr lang="en-US"/>
+          </a:p>
+        </p:txBody>
+      </p:sp>
+    </p:spTree>
+  </p:cSld>
+  <p:clrMapOvr>
+    <a:masterClrMapping/>
+  </p:clrMapOvr>
+</p:sld>
+</file>
+
+<file path=ppt/slides/slide22.xml><?xml version="1.0" encoding="utf-8"?>
+<p:sld xmlns:a="http://schemas.openxmlformats.org/drawingml/2006/main" xmlns:r="http://schemas.openxmlformats.org/officeDocument/2006/relationships" xmlns:p="http://schemas.openxmlformats.org/presentationml/2006/main">
+  <p:cSld name="Slide 22">
+    <p:spTree>
+      <p:nvGrpSpPr>
+        <p:cNvPr id="1" name=""/>
+        <p:cNvGrpSpPr/>
+        <p:nvPr/>
+      </p:nvGrpSpPr>
+      <p:grpSpPr>
+        <a:xfrm>
+          <a:off x="0" y="0"/>
+          <a:ext cx="0" cy="0"/>
+          <a:chOff x="0" y="0"/>
+          <a:chExt cx="0" cy="0"/>
+        </a:xfrm>
+      </p:grpSpPr>
+      <p:sp>
+        <p:nvSpPr>
+          <p:cNvPr id="2" name="Text 0"/>
+          <p:cNvSpPr/>
+          <p:nvPr>
+            <p:ph idx="100" type="title" hasCustomPrompt="1"/>
+          </p:nvPr>
+        </p:nvSpPr>
+        <p:spPr>
+          <a:xfrm>
+            <a:off x="548640" y="320040"/>
+            <a:ext cx="8046720" cy="685800"/>
+          </a:xfrm>
+          <a:prstGeom prst="rect">
+            <a:avLst/>
+          </a:prstGeom>
+          <a:noFill/>
+          <a:ln/>
+        </p:spPr>
+        <p:txBody>
+          <a:bodyPr wrap="square" lIns="0" tIns="0" rIns="0" bIns="0" rtlCol="0" anchor="ctr"/>
+          <a:lstStyle/>
+          <a:p>
+            <a:pPr indent="0" marL="0">
+              <a:buNone/>
+            </a:pPr>
+            <a:r>
+              <a:rPr lang="en-US" sz="3000" b="1" dirty="0">
+                <a:solidFill>
+                  <a:schemeClr val="bg1"/>
+                </a:solidFill>
+              </a:rPr>
+              <a:t>Más innovaciones en camino</a:t>
+            </a:r>
+            <a:endParaRPr lang="en-US" sz="3000" dirty="0"/>
+          </a:p>
+        </p:txBody>
+      </p:sp>
+      <p:sp>
+        <p:nvSpPr>
+          <p:cNvPr id="3" name="Etiqueta futuro fondo"/>
+          <p:cNvSpPr/>
+          <p:nvPr/>
+        </p:nvSpPr>
+        <p:spPr>
+          <a:xfrm>
+            <a:off x="6263640" y="457200"/>
+            <a:ext cx="2331720" cy="329184"/>
+          </a:xfrm>
+          <a:prstGeom prst="roundRect">
+            <a:avLst>
+              <a:gd name="adj" fmla="val 50000"/>
+            </a:avLst>
+          </a:prstGeom>
+          <a:solidFill>
+            <a:srgbClr val="2A1F4A"/>
+          </a:solidFill>
+          <a:ln w="12700">
+            <a:solidFill>
+              <a:srgbClr val="7C3AED"/>
+            </a:solidFill>
+            <a:prstDash val="solid"/>
+          </a:ln>
+        </p:spPr>
+      </p:sp>
+      <p:sp>
+        <p:nvSpPr>
+          <p:cNvPr id="4" name="Etiqueta futuro"/>
+          <p:cNvSpPr txBox="1"/>
+          <p:nvPr/>
+        </p:nvSpPr>
+        <p:spPr>
+          <a:xfrm>
+            <a:off x="6263640" y="457200"/>
+            <a:ext cx="2331720" cy="329184"/>
+          </a:xfrm>
+          <a:prstGeom prst="rect">
+            <a:avLst/>
+          </a:prstGeom>
+          <a:noFill/>
+          <a:ln/>
+        </p:spPr>
+        <p:txBody>
+          <a:bodyPr wrap="square" lIns="0" tIns="0" rIns="0" bIns="0" rtlCol="0" anchor="ctr"/>
+          <a:lstStyle/>
+          <a:p>
+            <a:pPr algn="ctr" indent="0" marL="0">
+              <a:buNone/>
+            </a:pPr>
+            <a:r>
+              <a:rPr lang="en-US" sz="900" b="1" dirty="0">
+                <a:solidFill>
+                  <a:srgbClr val="C4B5FD"/>
+                </a:solidFill>
+              </a:rPr>
+              <a:t>IDEAS DE FUTURO</a:t>
+            </a:r>
+            <a:endParaRPr lang="en-US" sz="900" dirty="0"/>
+          </a:p>
+        </p:txBody>
+      </p:sp>
+      <p:sp>
+        <p:nvSpPr>
+          <p:cNvPr id="5" name="Idea 1"/>
+          <p:cNvSpPr/>
+          <p:nvPr/>
+        </p:nvSpPr>
+        <p:spPr>
+          <a:xfrm>
+            <a:off x="548640" y="1188720"/>
+            <a:ext cx="3840480" cy="987552"/>
+          </a:xfrm>
+          <a:prstGeom prst="roundRect">
+            <a:avLst>
+              <a:gd name="adj" fmla="val 11111"/>
+            </a:avLst>
+          </a:prstGeom>
+          <a:solidFill>
+            <a:srgbClr val="1C1A2B"/>
+          </a:solidFill>
+          <a:ln w="9525">
+            <a:solidFill>
+              <a:srgbClr val="2E2A44"/>
+            </a:solidFill>
+            <a:prstDash val="solid"/>
+          </a:ln>
+        </p:spPr>
+      </p:sp>
+      <p:sp>
+        <p:nvSpPr>
+          <p:cNvPr id="6" name="Idea 1 círculo"/>
+          <p:cNvSpPr/>
+          <p:nvPr/>
+        </p:nvSpPr>
+        <p:spPr>
+          <a:xfrm>
+            <a:off x="731520" y="1371600"/>
+            <a:ext cx="621792" cy="621792"/>
+          </a:xfrm>
+          <a:prstGeom prst="ellipse">
+            <a:avLst/>
+          </a:prstGeom>
+          <a:solidFill>
+            <a:srgbClr val="7C3AED"/>
+          </a:solidFill>
+          <a:ln w="12700">
+            <a:solidFill>
+              <a:srgbClr val="7C3AED"/>
+            </a:solidFill>
+            <a:prstDash val="solid"/>
+          </a:ln>
+        </p:spPr>
+      </p:sp>
+      <p:pic>
+        <p:nvPicPr>
+          <p:cNvPr id="7" name="Idea 1 ícono" descr="preencoded.png">    </p:cNvPr>
+          <p:cNvPicPr>
+            <a:picLocks noChangeAspect="1"/>
+          </p:cNvPicPr>
+          <p:nvPr/>
+        </p:nvPicPr>
+        <p:blipFill>
+          <a:blip r:embed="rId1"/>
+          <a:stretch>
+            <a:fillRect/>
+          </a:stretch>
+        </p:blipFill>
+        <p:spPr>
+          <a:xfrm>
+            <a:off x="880750" y="1520830"/>
+            <a:ext cx="323332" cy="323332"/>
+          </a:xfrm>
+          <a:prstGeom prst="rect">
+            <a:avLst/>
+          </a:prstGeom>
+        </p:spPr>
+      </p:pic>
+      <p:sp>
+        <p:nvSpPr>
+          <p:cNvPr id="8" name="Idea título 1"/>
+          <p:cNvSpPr txBox="1"/>
+          <p:nvPr/>
+        </p:nvSpPr>
+        <p:spPr>
+          <a:xfrm>
+            <a:off x="1554480" y="1344168"/>
+            <a:ext cx="2697480" cy="292608"/>
+          </a:xfrm>
+          <a:prstGeom prst="rect">
+            <a:avLst/>
+          </a:prstGeom>
+          <a:noFill/>
+          <a:ln/>
+        </p:spPr>
+        <p:txBody>
+          <a:bodyPr wrap="square" lIns="0" tIns="0" rIns="0" bIns="0" rtlCol="0" anchor="ctr"/>
+          <a:lstStyle/>
+          <a:p>
+            <a:pPr indent="0" marL="0">
+              <a:buNone/>
+            </a:pPr>
+            <a:r>
+              <a:rPr lang="en-US" sz="1500" b="1" dirty="0">
+                <a:solidFill>
+                  <a:srgbClr val="FFFFFF"/>
+                </a:solidFill>
+                <a:latin typeface="Arial" pitchFamily="34" charset="0"/>
+                <a:ea typeface="Arial" pitchFamily="34" charset="-122"/>
+                <a:cs typeface="Arial" pitchFamily="34" charset="-120"/>
+              </a:rPr>
+              <a:t>Laya atiende WhatsApp</a:t>
+            </a:r>
+            <a:endParaRPr lang="en-US" sz="1500" dirty="0"/>
+          </a:p>
+        </p:txBody>
+      </p:sp>
+      <p:sp>
+        <p:nvSpPr>
+          <p:cNvPr id="9" name="Idea texto 1"/>
+          <p:cNvSpPr txBox="1"/>
+          <p:nvPr/>
+        </p:nvSpPr>
+        <p:spPr>
+          <a:xfrm>
+            <a:off x="1554480" y="1664208"/>
+            <a:ext cx="2697480" cy="411480"/>
+          </a:xfrm>
+          <a:prstGeom prst="rect">
+            <a:avLst/>
+          </a:prstGeom>
+          <a:noFill/>
+          <a:ln/>
+        </p:spPr>
+        <p:txBody>
+          <a:bodyPr wrap="square" lIns="0" tIns="0" rIns="0" bIns="0" rtlCol="0" anchor="t"/>
+          <a:lstStyle/>
+          <a:p>
+            <a:pPr indent="0" marL="0">
+              <a:buNone/>
+            </a:pPr>
+            <a:r>
+              <a:rPr lang="en-US" sz="1200" dirty="0">
+                <a:solidFill>
+                  <a:srgbClr val="A9A6BD"/>
+                </a:solidFill>
+              </a:rPr>
+              <a:t>Toma domicilios y responde a los clientes sola.</a:t>
+            </a:r>
+            <a:endParaRPr lang="en-US" sz="1200" dirty="0"/>
+          </a:p>
+        </p:txBody>
+      </p:sp>
+      <p:sp>
+        <p:nvSpPr>
+          <p:cNvPr id="10" name="Idea 2"/>
+          <p:cNvSpPr/>
+          <p:nvPr/>
+        </p:nvSpPr>
+        <p:spPr>
+          <a:xfrm>
+            <a:off x="4617720" y="1188720"/>
+            <a:ext cx="3840480" cy="987552"/>
+          </a:xfrm>
+          <a:prstGeom prst="roundRect">
+            <a:avLst>
+              <a:gd name="adj" fmla="val 11111"/>
+            </a:avLst>
+          </a:prstGeom>
+          <a:solidFill>
+            <a:srgbClr val="1C1A2B"/>
+          </a:solidFill>
+          <a:ln w="9525">
+            <a:solidFill>
+              <a:srgbClr val="2E2A44"/>
+            </a:solidFill>
+            <a:prstDash val="solid"/>
+          </a:ln>
+        </p:spPr>
+      </p:sp>
+      <p:sp>
+        <p:nvSpPr>
+          <p:cNvPr id="11" name="Idea 2 círculo"/>
+          <p:cNvSpPr/>
+          <p:nvPr/>
+        </p:nvSpPr>
+        <p:spPr>
+          <a:xfrm>
+            <a:off x="4800600" y="1371600"/>
+            <a:ext cx="621792" cy="621792"/>
+          </a:xfrm>
+          <a:prstGeom prst="ellipse">
+            <a:avLst/>
+          </a:prstGeom>
+          <a:solidFill>
+            <a:srgbClr val="7C3AED"/>
+          </a:solidFill>
+          <a:ln w="12700">
+            <a:solidFill>
+              <a:srgbClr val="7C3AED"/>
+            </a:solidFill>
+            <a:prstDash val="solid"/>
+          </a:ln>
+        </p:spPr>
+      </p:sp>
+      <p:pic>
+        <p:nvPicPr>
+          <p:cNvPr id="12" name="Idea 2 ícono" descr="preencoded.png">    </p:cNvPr>
+          <p:cNvPicPr>
+            <a:picLocks noChangeAspect="1"/>
+          </p:cNvPicPr>
+          <p:nvPr/>
+        </p:nvPicPr>
+        <p:blipFill>
+          <a:blip r:embed="rId2"/>
+          <a:stretch>
+            <a:fillRect/>
+          </a:stretch>
+        </p:blipFill>
+        <p:spPr>
+          <a:xfrm>
+            <a:off x="4949830" y="1520830"/>
+            <a:ext cx="323332" cy="323332"/>
+          </a:xfrm>
+          <a:prstGeom prst="rect">
+            <a:avLst/>
+          </a:prstGeom>
+        </p:spPr>
+      </p:pic>
+      <p:sp>
+        <p:nvSpPr>
+          <p:cNvPr id="13" name="Idea título 2"/>
+          <p:cNvSpPr txBox="1"/>
+          <p:nvPr/>
+        </p:nvSpPr>
+        <p:spPr>
+          <a:xfrm>
+            <a:off x="5623560" y="1344168"/>
+            <a:ext cx="2697480" cy="292608"/>
+          </a:xfrm>
+          <a:prstGeom prst="rect">
+            <a:avLst/>
+          </a:prstGeom>
+          <a:noFill/>
+          <a:ln/>
+        </p:spPr>
+        <p:txBody>
+          <a:bodyPr wrap="square" lIns="0" tIns="0" rIns="0" bIns="0" rtlCol="0" anchor="ctr"/>
+          <a:lstStyle/>
+          <a:p>
+            <a:pPr indent="0" marL="0">
+              <a:buNone/>
+            </a:pPr>
+            <a:r>
+              <a:rPr lang="en-US" sz="1500" b="1" dirty="0">
+                <a:solidFill>
+                  <a:srgbClr val="FFFFFF"/>
+                </a:solidFill>
+                <a:latin typeface="Arial" pitchFamily="34" charset="0"/>
+                <a:ea typeface="Arial" pitchFamily="34" charset="-122"/>
+                <a:cs typeface="Arial" pitchFamily="34" charset="-120"/>
+              </a:rPr>
+              <a:t>Cámara que cuenta</a:t>
+            </a:r>
+            <a:endParaRPr lang="en-US" sz="1500" dirty="0"/>
+          </a:p>
+        </p:txBody>
+      </p:sp>
+      <p:sp>
+        <p:nvSpPr>
+          <p:cNvPr id="14" name="Idea texto 2"/>
+          <p:cNvSpPr txBox="1"/>
+          <p:nvPr/>
+        </p:nvSpPr>
+        <p:spPr>
+          <a:xfrm>
+            <a:off x="5623560" y="1664208"/>
+            <a:ext cx="2697480" cy="411480"/>
+          </a:xfrm>
+          <a:prstGeom prst="rect">
+            <a:avLst/>
+          </a:prstGeom>
+          <a:noFill/>
+          <a:ln/>
+        </p:spPr>
+        <p:txBody>
+          <a:bodyPr wrap="square" lIns="0" tIns="0" rIns="0" bIns="0" rtlCol="0" anchor="t"/>
+          <a:lstStyle/>
+          <a:p>
+            <a:pPr indent="0" marL="0">
+              <a:buNone/>
+            </a:pPr>
+            <a:r>
+              <a:rPr lang="en-US" sz="1200" dirty="0">
+                <a:solidFill>
+                  <a:srgbClr val="A9A6BD"/>
+                </a:solidFill>
+              </a:rPr>
+              <a:t>Una foto a la nevera y sabe cuántas botellas quedan.</a:t>
+            </a:r>
+            <a:endParaRPr lang="en-US" sz="1200" dirty="0"/>
+          </a:p>
+        </p:txBody>
+      </p:sp>
+      <p:sp>
+        <p:nvSpPr>
+          <p:cNvPr id="15" name="Idea 3"/>
+          <p:cNvSpPr/>
+          <p:nvPr/>
+        </p:nvSpPr>
+        <p:spPr>
+          <a:xfrm>
+            <a:off x="548640" y="2331720"/>
+            <a:ext cx="3840480" cy="987552"/>
+          </a:xfrm>
+          <a:prstGeom prst="roundRect">
+            <a:avLst>
+              <a:gd name="adj" fmla="val 11111"/>
+            </a:avLst>
+          </a:prstGeom>
+          <a:solidFill>
+            <a:srgbClr val="1C1A2B"/>
+          </a:solidFill>
+          <a:ln w="9525">
+            <a:solidFill>
+              <a:srgbClr val="2E2A44"/>
+            </a:solidFill>
+            <a:prstDash val="solid"/>
+          </a:ln>
+        </p:spPr>
+      </p:sp>
+      <p:sp>
+        <p:nvSpPr>
+          <p:cNvPr id="16" name="Idea 3 círculo"/>
+          <p:cNvSpPr/>
+          <p:nvPr/>
+        </p:nvSpPr>
+        <p:spPr>
+          <a:xfrm>
+            <a:off x="731520" y="2514600"/>
+            <a:ext cx="621792" cy="621792"/>
+          </a:xfrm>
+          <a:prstGeom prst="ellipse">
+            <a:avLst/>
+          </a:prstGeom>
+          <a:solidFill>
+            <a:srgbClr val="7C3AED"/>
+          </a:solidFill>
+          <a:ln w="12700">
+            <a:solidFill>
+              <a:srgbClr val="7C3AED"/>
+            </a:solidFill>
+            <a:prstDash val="solid"/>
+          </a:ln>
+        </p:spPr>
+      </p:sp>
+      <p:pic>
+        <p:nvPicPr>
+          <p:cNvPr id="17" name="Idea 3 ícono" descr="preencoded.png">    </p:cNvPr>
+          <p:cNvPicPr>
+            <a:picLocks noChangeAspect="1"/>
+          </p:cNvPicPr>
+          <p:nvPr/>
+        </p:nvPicPr>
+        <p:blipFill>
+          <a:blip r:embed="rId3"/>
+          <a:stretch>
+            <a:fillRect/>
+          </a:stretch>
+        </p:blipFill>
+        <p:spPr>
+          <a:xfrm>
+            <a:off x="880750" y="2663830"/>
+            <a:ext cx="323332" cy="323332"/>
+          </a:xfrm>
+          <a:prstGeom prst="rect">
+            <a:avLst/>
+          </a:prstGeom>
+        </p:spPr>
+      </p:pic>
+      <p:sp>
+        <p:nvSpPr>
+          <p:cNvPr id="18" name="Idea título 3"/>
+          <p:cNvSpPr txBox="1"/>
+          <p:nvPr/>
+        </p:nvSpPr>
+        <p:spPr>
+          <a:xfrm>
+            <a:off x="1554480" y="2487168"/>
+            <a:ext cx="2697480" cy="292608"/>
+          </a:xfrm>
+          <a:prstGeom prst="rect">
+            <a:avLst/>
+          </a:prstGeom>
+          <a:noFill/>
+          <a:ln/>
+        </p:spPr>
+        <p:txBody>
+          <a:bodyPr wrap="square" lIns="0" tIns="0" rIns="0" bIns="0" rtlCol="0" anchor="ctr"/>
+          <a:lstStyle/>
+          <a:p>
+            <a:pPr indent="0" marL="0">
+              <a:buNone/>
+            </a:pPr>
+            <a:r>
+              <a:rPr lang="en-US" sz="1500" b="1" dirty="0">
+                <a:solidFill>
+                  <a:srgbClr val="FFFFFF"/>
+                </a:solidFill>
+                <a:latin typeface="Arial" pitchFamily="34" charset="0"/>
+                <a:ea typeface="Arial" pitchFamily="34" charset="-122"/>
+                <a:cs typeface="Arial" pitchFamily="34" charset="-120"/>
+              </a:rPr>
+              <a:t>El TV como vitrina</a:t>
+            </a:r>
+            <a:endParaRPr lang="en-US" sz="1500" dirty="0"/>
+          </a:p>
+        </p:txBody>
+      </p:sp>
+      <p:sp>
+        <p:nvSpPr>
+          <p:cNvPr id="19" name="Idea texto 3"/>
+          <p:cNvSpPr txBox="1"/>
+          <p:nvPr/>
+        </p:nvSpPr>
+        <p:spPr>
+          <a:xfrm>
+            <a:off x="1554480" y="2807208"/>
+            <a:ext cx="2697480" cy="411480"/>
+          </a:xfrm>
+          <a:prstGeom prst="rect">
+            <a:avLst/>
+          </a:prstGeom>
+          <a:noFill/>
+          <a:ln/>
+        </p:spPr>
+        <p:txBody>
+          <a:bodyPr wrap="square" lIns="0" tIns="0" rIns="0" bIns="0" rtlCol="0" anchor="t"/>
+          <a:lstStyle/>
+          <a:p>
+            <a:pPr indent="0" marL="0">
+              <a:buNone/>
+            </a:pPr>
+            <a:r>
+              <a:rPr lang="en-US" sz="1200" dirty="0">
+                <a:solidFill>
+                  <a:srgbClr val="A9A6BD"/>
+                </a:solidFill>
+              </a:rPr>
+              <a:t>Muestra la carta, promociones y la cola de canciones.</a:t>
+            </a:r>
+            <a:endParaRPr lang="en-US" sz="1200" dirty="0"/>
+          </a:p>
+        </p:txBody>
+      </p:sp>
+      <p:sp>
+        <p:nvSpPr>
+          <p:cNvPr id="20" name="Idea 4"/>
+          <p:cNvSpPr/>
+          <p:nvPr/>
+        </p:nvSpPr>
+        <p:spPr>
+          <a:xfrm>
+            <a:off x="4617720" y="2331720"/>
+            <a:ext cx="3840480" cy="987552"/>
+          </a:xfrm>
+          <a:prstGeom prst="roundRect">
+            <a:avLst>
+              <a:gd name="adj" fmla="val 11111"/>
+            </a:avLst>
+          </a:prstGeom>
+          <a:solidFill>
+            <a:srgbClr val="1C1A2B"/>
+          </a:solidFill>
+          <a:ln w="9525">
+            <a:solidFill>
+              <a:srgbClr val="2E2A44"/>
+            </a:solidFill>
+            <a:prstDash val="solid"/>
+          </a:ln>
+        </p:spPr>
+      </p:sp>
+      <p:sp>
+        <p:nvSpPr>
+          <p:cNvPr id="21" name="Idea 4 círculo"/>
+          <p:cNvSpPr/>
+          <p:nvPr/>
+        </p:nvSpPr>
+        <p:spPr>
+          <a:xfrm>
+            <a:off x="4800600" y="2514600"/>
+            <a:ext cx="621792" cy="621792"/>
+          </a:xfrm>
+          <a:prstGeom prst="ellipse">
+            <a:avLst/>
+          </a:prstGeom>
+          <a:solidFill>
+            <a:srgbClr val="7C3AED"/>
+          </a:solidFill>
+          <a:ln w="12700">
+            <a:solidFill>
+              <a:srgbClr val="7C3AED"/>
+            </a:solidFill>
+            <a:prstDash val="solid"/>
+          </a:ln>
+        </p:spPr>
+      </p:sp>
+      <p:pic>
+        <p:nvPicPr>
+          <p:cNvPr id="22" name="Idea 4 ícono" descr="preencoded.png">    </p:cNvPr>
+          <p:cNvPicPr>
+            <a:picLocks noChangeAspect="1"/>
+          </p:cNvPicPr>
+          <p:nvPr/>
+        </p:nvPicPr>
+        <p:blipFill>
+          <a:blip r:embed="rId4"/>
+          <a:stretch>
+            <a:fillRect/>
+          </a:stretch>
+        </p:blipFill>
+        <p:spPr>
+          <a:xfrm>
+            <a:off x="4949830" y="2663830"/>
+            <a:ext cx="323332" cy="323332"/>
+          </a:xfrm>
+          <a:prstGeom prst="rect">
+            <a:avLst/>
+          </a:prstGeom>
+        </p:spPr>
+      </p:pic>
+      <p:sp>
+        <p:nvSpPr>
+          <p:cNvPr id="23" name="Idea título 4"/>
+          <p:cNvSpPr txBox="1"/>
+          <p:nvPr/>
+        </p:nvSpPr>
+        <p:spPr>
+          <a:xfrm>
+            <a:off x="5623560" y="2487168"/>
+            <a:ext cx="2697480" cy="292608"/>
+          </a:xfrm>
+          <a:prstGeom prst="rect">
+            <a:avLst/>
+          </a:prstGeom>
+          <a:noFill/>
+          <a:ln/>
+        </p:spPr>
+        <p:txBody>
+          <a:bodyPr wrap="square" lIns="0" tIns="0" rIns="0" bIns="0" rtlCol="0" anchor="ctr"/>
+          <a:lstStyle/>
+          <a:p>
+            <a:pPr indent="0" marL="0">
+              <a:buNone/>
+            </a:pPr>
+            <a:r>
+              <a:rPr lang="en-US" sz="1500" b="1" dirty="0">
+                <a:solidFill>
+                  <a:srgbClr val="FFFFFF"/>
+                </a:solidFill>
+                <a:latin typeface="Arial" pitchFamily="34" charset="0"/>
+                <a:ea typeface="Arial" pitchFamily="34" charset="-122"/>
+                <a:cs typeface="Arial" pitchFamily="34" charset="-120"/>
+              </a:rPr>
+              <a:t>Habla con turistas</a:t>
+            </a:r>
+            <a:endParaRPr lang="en-US" sz="1500" dirty="0"/>
+          </a:p>
+        </p:txBody>
+      </p:sp>
+      <p:sp>
+        <p:nvSpPr>
+          <p:cNvPr id="24" name="Idea texto 4"/>
+          <p:cNvSpPr txBox="1"/>
+          <p:nvPr/>
+        </p:nvSpPr>
+        <p:spPr>
+          <a:xfrm>
+            <a:off x="5623560" y="2807208"/>
+            <a:ext cx="2697480" cy="411480"/>
+          </a:xfrm>
+          <a:prstGeom prst="rect">
+            <a:avLst/>
+          </a:prstGeom>
+          <a:noFill/>
+          <a:ln/>
+        </p:spPr>
+        <p:txBody>
+          <a:bodyPr wrap="square" lIns="0" tIns="0" rIns="0" bIns="0" rtlCol="0" anchor="t"/>
+          <a:lstStyle/>
+          <a:p>
+            <a:pPr indent="0" marL="0">
+              <a:buNone/>
+            </a:pPr>
+            <a:r>
+              <a:rPr lang="en-US" sz="1200" dirty="0">
+                <a:solidFill>
+                  <a:srgbClr val="A9A6BD"/>
+                </a:solidFill>
+              </a:rPr>
+              <a:t>Carta y pedidos por QR en inglés y otros idiomas.</a:t>
+            </a:r>
+            <a:endParaRPr lang="en-US" sz="1200" dirty="0"/>
+          </a:p>
+        </p:txBody>
+      </p:sp>
+      <p:sp>
+        <p:nvSpPr>
+          <p:cNvPr id="25" name="Idea 5"/>
+          <p:cNvSpPr/>
+          <p:nvPr/>
+        </p:nvSpPr>
+        <p:spPr>
+          <a:xfrm>
+            <a:off x="548640" y="3474720"/>
+            <a:ext cx="3840480" cy="987552"/>
+          </a:xfrm>
+          <a:prstGeom prst="roundRect">
+            <a:avLst>
+              <a:gd name="adj" fmla="val 11111"/>
+            </a:avLst>
+          </a:prstGeom>
+          <a:solidFill>
+            <a:srgbClr val="1C1A2B"/>
+          </a:solidFill>
+          <a:ln w="9525">
+            <a:solidFill>
+              <a:srgbClr val="2E2A44"/>
+            </a:solidFill>
+            <a:prstDash val="solid"/>
+          </a:ln>
+        </p:spPr>
+      </p:sp>
+      <p:sp>
+        <p:nvSpPr>
+          <p:cNvPr id="26" name="Idea 5 círculo"/>
+          <p:cNvSpPr/>
+          <p:nvPr/>
+        </p:nvSpPr>
+        <p:spPr>
+          <a:xfrm>
+            <a:off x="731520" y="3657600"/>
+            <a:ext cx="621792" cy="621792"/>
+          </a:xfrm>
+          <a:prstGeom prst="ellipse">
+            <a:avLst/>
+          </a:prstGeom>
+          <a:solidFill>
+            <a:srgbClr val="7C3AED"/>
+          </a:solidFill>
+          <a:ln w="12700">
+            <a:solidFill>
+              <a:srgbClr val="7C3AED"/>
+            </a:solidFill>
+            <a:prstDash val="solid"/>
+          </a:ln>
+        </p:spPr>
+      </p:sp>
+      <p:pic>
+        <p:nvPicPr>
+          <p:cNvPr id="27" name="Idea 5 ícono" descr="preencoded.png">    </p:cNvPr>
+          <p:cNvPicPr>
+            <a:picLocks noChangeAspect="1"/>
+          </p:cNvPicPr>
+          <p:nvPr/>
+        </p:nvPicPr>
+        <p:blipFill>
+          <a:blip r:embed="rId5"/>
+          <a:stretch>
+            <a:fillRect/>
+          </a:stretch>
+        </p:blipFill>
+        <p:spPr>
+          <a:xfrm>
+            <a:off x="880750" y="3806830"/>
+            <a:ext cx="323332" cy="323332"/>
+          </a:xfrm>
+          <a:prstGeom prst="rect">
+            <a:avLst/>
+          </a:prstGeom>
+        </p:spPr>
+      </p:pic>
+      <p:sp>
+        <p:nvSpPr>
+          <p:cNvPr id="28" name="Idea título 5"/>
+          <p:cNvSpPr txBox="1"/>
+          <p:nvPr/>
+        </p:nvSpPr>
+        <p:spPr>
+          <a:xfrm>
+            <a:off x="1554480" y="3630168"/>
+            <a:ext cx="2697480" cy="292608"/>
+          </a:xfrm>
+          <a:prstGeom prst="rect">
+            <a:avLst/>
+          </a:prstGeom>
+          <a:noFill/>
+          <a:ln/>
+        </p:spPr>
+        <p:txBody>
+          <a:bodyPr wrap="square" lIns="0" tIns="0" rIns="0" bIns="0" rtlCol="0" anchor="ctr"/>
+          <a:lstStyle/>
+          <a:p>
+            <a:pPr indent="0" marL="0">
+              <a:buNone/>
+            </a:pPr>
+            <a:r>
+              <a:rPr lang="en-US" sz="1500" b="1" dirty="0">
+                <a:solidFill>
+                  <a:srgbClr val="FFFFFF"/>
+                </a:solidFill>
+                <a:latin typeface="Arial" pitchFamily="34" charset="0"/>
+                <a:ea typeface="Arial" pitchFamily="34" charset="-122"/>
+                <a:cs typeface="Arial" pitchFamily="34" charset="-120"/>
+              </a:rPr>
+              <a:t>Informe de cada noche</a:t>
+            </a:r>
+            <a:endParaRPr lang="en-US" sz="1500" dirty="0"/>
+          </a:p>
+        </p:txBody>
+      </p:sp>
+      <p:sp>
+        <p:nvSpPr>
+          <p:cNvPr id="29" name="Idea texto 5"/>
+          <p:cNvSpPr txBox="1"/>
+          <p:nvPr/>
+        </p:nvSpPr>
+        <p:spPr>
+          <a:xfrm>
+            <a:off x="1554480" y="3950208"/>
+            <a:ext cx="2697480" cy="411480"/>
+          </a:xfrm>
+          <a:prstGeom prst="rect">
+            <a:avLst/>
+          </a:prstGeom>
+          <a:noFill/>
+          <a:ln/>
+        </p:spPr>
+        <p:txBody>
+          <a:bodyPr wrap="square" lIns="0" tIns="0" rIns="0" bIns="0" rtlCol="0" anchor="t"/>
+          <a:lstStyle/>
+          <a:p>
+            <a:pPr indent="0" marL="0">
+              <a:buNone/>
+            </a:pPr>
+            <a:r>
+              <a:rPr lang="en-US" sz="1200" dirty="0">
+                <a:solidFill>
+                  <a:srgbClr val="A9A6BD"/>
+                </a:solidFill>
+              </a:rPr>
+              <a:t>Al cerrar, Vento le cuenta al dueño cómo le fue, por voz.</a:t>
+            </a:r>
+            <a:endParaRPr lang="en-US" sz="1200" dirty="0"/>
+          </a:p>
+        </p:txBody>
+      </p:sp>
+      <p:sp>
+        <p:nvSpPr>
+          <p:cNvPr id="30" name="Idea 6"/>
+          <p:cNvSpPr/>
+          <p:nvPr/>
+        </p:nvSpPr>
+        <p:spPr>
+          <a:xfrm>
+            <a:off x="4617720" y="3474720"/>
+            <a:ext cx="3840480" cy="987552"/>
+          </a:xfrm>
+          <a:prstGeom prst="roundRect">
+            <a:avLst>
+              <a:gd name="adj" fmla="val 11111"/>
+            </a:avLst>
+          </a:prstGeom>
+          <a:solidFill>
+            <a:srgbClr val="1C1A2B"/>
+          </a:solidFill>
+          <a:ln w="9525">
+            <a:solidFill>
+              <a:srgbClr val="2E2A44"/>
+            </a:solidFill>
+            <a:prstDash val="solid"/>
+          </a:ln>
+        </p:spPr>
+      </p:sp>
+      <p:sp>
+        <p:nvSpPr>
+          <p:cNvPr id="31" name="Idea 6 círculo"/>
+          <p:cNvSpPr/>
+          <p:nvPr/>
+        </p:nvSpPr>
+        <p:spPr>
+          <a:xfrm>
+            <a:off x="4800600" y="3657600"/>
+            <a:ext cx="621792" cy="621792"/>
+          </a:xfrm>
+          <a:prstGeom prst="ellipse">
+            <a:avLst/>
+          </a:prstGeom>
+          <a:solidFill>
+            <a:srgbClr val="7C3AED"/>
+          </a:solidFill>
+          <a:ln w="12700">
+            <a:solidFill>
+              <a:srgbClr val="7C3AED"/>
+            </a:solidFill>
+            <a:prstDash val="solid"/>
+          </a:ln>
+        </p:spPr>
+      </p:sp>
+      <p:pic>
+        <p:nvPicPr>
+          <p:cNvPr id="32" name="Idea 6 ícono" descr="preencoded.png">    </p:cNvPr>
+          <p:cNvPicPr>
+            <a:picLocks noChangeAspect="1"/>
+          </p:cNvPicPr>
+          <p:nvPr/>
+        </p:nvPicPr>
+        <p:blipFill>
+          <a:blip r:embed="rId6"/>
+          <a:stretch>
+            <a:fillRect/>
+          </a:stretch>
+        </p:blipFill>
+        <p:spPr>
+          <a:xfrm>
+            <a:off x="4949830" y="3806830"/>
+            <a:ext cx="323332" cy="323332"/>
+          </a:xfrm>
+          <a:prstGeom prst="rect">
+            <a:avLst/>
+          </a:prstGeom>
+        </p:spPr>
+      </p:pic>
+      <p:sp>
+        <p:nvSpPr>
+          <p:cNvPr id="33" name="Idea título 6"/>
+          <p:cNvSpPr txBox="1"/>
+          <p:nvPr/>
+        </p:nvSpPr>
+        <p:spPr>
+          <a:xfrm>
+            <a:off x="5623560" y="3630168"/>
+            <a:ext cx="2697480" cy="292608"/>
+          </a:xfrm>
+          <a:prstGeom prst="rect">
+            <a:avLst/>
+          </a:prstGeom>
+          <a:noFill/>
+          <a:ln/>
+        </p:spPr>
+        <p:txBody>
+          <a:bodyPr wrap="square" lIns="0" tIns="0" rIns="0" bIns="0" rtlCol="0" anchor="ctr"/>
+          <a:lstStyle/>
+          <a:p>
+            <a:pPr indent="0" marL="0">
+              <a:buNone/>
+            </a:pPr>
+            <a:r>
+              <a:rPr lang="en-US" sz="1500" b="1" dirty="0">
+                <a:solidFill>
+                  <a:srgbClr val="FFFFFF"/>
+                </a:solidFill>
+                <a:latin typeface="Arial" pitchFamily="34" charset="0"/>
+                <a:ea typeface="Arial" pitchFamily="34" charset="-122"/>
+                <a:cs typeface="Arial" pitchFamily="34" charset="-120"/>
+              </a:rPr>
+              <a:t>Soporte por voz</a:t>
+            </a:r>
+            <a:endParaRPr lang="en-US" sz="1500" dirty="0"/>
+          </a:p>
+        </p:txBody>
+      </p:sp>
+      <p:sp>
+        <p:nvSpPr>
+          <p:cNvPr id="34" name="Idea texto 6"/>
+          <p:cNvSpPr txBox="1"/>
+          <p:nvPr/>
+        </p:nvSpPr>
+        <p:spPr>
+          <a:xfrm>
+            <a:off x="5623560" y="3950208"/>
+            <a:ext cx="2697480" cy="411480"/>
+          </a:xfrm>
+          <a:prstGeom prst="rect">
+            <a:avLst/>
+          </a:prstGeom>
+          <a:noFill/>
+          <a:ln/>
+        </p:spPr>
+        <p:txBody>
+          <a:bodyPr wrap="square" lIns="0" tIns="0" rIns="0" bIns="0" rtlCol="0" anchor="t"/>
+          <a:lstStyle/>
+          <a:p>
+            <a:pPr indent="0" marL="0">
+              <a:buNone/>
+            </a:pPr>
+            <a:r>
+              <a:rPr lang="en-US" sz="1200" dirty="0">
+                <a:solidFill>
+                  <a:srgbClr val="A9A6BD"/>
+                </a:solidFill>
+              </a:rPr>
+              <a:t>«Vento, ¿cómo hago…?» y te guía en ese momento.</a:t>
+            </a:r>
+            <a:endParaRPr lang="en-US" sz="1200" dirty="0"/>
+          </a:p>
+        </p:txBody>
+      </p:sp>
+      <p:sp>
+        <p:nvSpPr>
+          <p:cNvPr id="25" name="Slide Number Placeholder 0"/>
+          <p:cNvSpPr>
+            <a:spLocks noGrp="1"/>
+          </p:cNvSpPr>
+          <p:nvPr>
+            <p:ph type="sldNum" sz="quarter" idx="4294967295"/>
+          </p:nvPr>
+        </p:nvSpPr>
+        <p:spPr>
+          <a:xfrm>
+            <a:off x="8412480" y="4754880"/>
+            <a:ext cx="457200" cy="274320"/>
+          </a:xfrm>
+          <a:prstGeom prst="rect">
+            <a:avLst/>
+          </a:prstGeom>
+          <a:extLst>
+            <a:ext uri="{C572A759-6A51-4108-AA02-DFA0A04FC94B}">
+              <ma14:wrappingTextBoxFlag xmlns:ma14="http://schemas.microsoft.com/office/mac/drawingml/2011/main" val="0"/>
+            </a:ext>
+          </a:extLst>
+        </p:spPr>
+        <p:txBody>
+          <a:bodyPr/>
+          <a:lstStyle>
+            <a:lvl1pPr>
+              <a:defRPr sz="1000">
+                <a:solidFill>
+                  <a:srgbClr val="9A97AD"/>
+                </a:solidFill>
+              </a:defRPr>
+            </a:lvl1pPr>
+          </a:lstStyle>
+          <a:p>
+            <a:pPr algn="r"/>
+            <a:fld id="{F7021451-1387-4CA6-816F-3879F97B5CBC}" type="slidenum">
+              <a:rPr b="0" lang="en-US"/>
+              <a:t>22</a:t>
+            </a:fld>
+            <a:endParaRPr lang="en-US"/>
+          </a:p>
+        </p:txBody>
+      </p:sp>
+    </p:spTree>
+  </p:cSld>
+  <p:clrMapOvr>
+    <a:masterClrMapping/>
+  </p:clrMapOvr>
+</p:sld>
+</file>
+
+<file path=ppt/slides/slide23.xml><?xml version="1.0" encoding="utf-8"?>
+<p:sld xmlns:a="http://schemas.openxmlformats.org/drawingml/2006/main" xmlns:r="http://schemas.openxmlformats.org/officeDocument/2006/relationships" xmlns:p="http://schemas.openxmlformats.org/presentationml/2006/main">
+  <p:cSld name="Slide 23">
+    <p:spTree>
+      <p:nvGrpSpPr>
+        <p:cNvPr id="1" name=""/>
+        <p:cNvGrpSpPr/>
+        <p:nvPr/>
+      </p:nvGrpSpPr>
+      <p:grpSpPr>
+        <a:xfrm>
+          <a:off x="0" y="0"/>
+          <a:ext cx="0" cy="0"/>
+          <a:chOff x="0" y="0"/>
+          <a:chExt cx="0" cy="0"/>
+        </a:xfrm>
+      </p:grpSpPr>
+      <p:pic>
+        <p:nvPicPr>
+          <p:cNvPr id="2" name="Logo Vento cierre" descr="preencoded.png">    </p:cNvPr>
+          <p:cNvPicPr>
+            <a:picLocks noChangeAspect="1"/>
+          </p:cNvPicPr>
+          <p:nvPr/>
+        </p:nvPicPr>
+        <p:blipFill>
+          <a:blip r:embed="rId1"/>
+          <a:stretch>
+            <a:fillRect/>
+          </a:stretch>
+        </p:blipFill>
+        <p:spPr>
+          <a:xfrm>
+            <a:off x="548640" y="502920"/>
+            <a:ext cx="685800" cy="685800"/>
+          </a:xfrm>
+          <a:prstGeom prst="rect">
+            <a:avLst/>
+          </a:prstGeom>
+        </p:spPr>
+      </p:pic>
+      <p:sp>
+        <p:nvSpPr>
+          <p:cNvPr id="3" name="Text 0"/>
+          <p:cNvSpPr/>
+          <p:nvPr>
+            <p:ph idx="100" type="title" hasCustomPrompt="1"/>
+          </p:nvPr>
+        </p:nvSpPr>
+        <p:spPr>
+          <a:xfrm>
+            <a:off x="548640" y="1234440"/>
+            <a:ext cx="4572000" cy="1188720"/>
+          </a:xfrm>
+          <a:prstGeom prst="rect">
+            <a:avLst/>
+          </a:prstGeom>
+          <a:noFill/>
+          <a:ln/>
+        </p:spPr>
+        <p:txBody>
+          <a:bodyPr wrap="square" lIns="0" tIns="0" rIns="0" bIns="0" rtlCol="0" anchor="b"/>
+          <a:lstStyle/>
+          <a:p>
+            <a:pPr indent="0" marL="0">
+              <a:buNone/>
+            </a:pPr>
+            <a:r>
+              <a:rPr lang="en-US" sz="3600" b="1" dirty="0">
+                <a:solidFill>
+                  <a:schemeClr val="bg1"/>
+                </a:solidFill>
+              </a:rPr>
+              <a:t>Vento trabaja por ti</a:t>
+            </a:r>
+            <a:endParaRPr lang="en-US" sz="5400" dirty="0"/>
+          </a:p>
+        </p:txBody>
+      </p:sp>
+      <p:sp>
+        <p:nvSpPr>
+          <p:cNvPr id="4" name="Text 0"/>
+          <p:cNvSpPr/>
+          <p:nvPr>
+            <p:ph idx="101" type="body" hasCustomPrompt="1"/>
+          </p:nvPr>
+        </p:nvSpPr>
+        <p:spPr>
+          <a:xfrm>
+            <a:off x="548640" y="2514600"/>
+            <a:ext cx="4480560" cy="1463040"/>
+          </a:xfrm>
+          <a:prstGeom prst="rect">
+            <a:avLst/>
+          </a:prstGeom>
+          <a:noFill/>
+          <a:ln/>
+        </p:spPr>
+        <p:txBody>
+          <a:bodyPr wrap="square" lIns="0" tIns="0" rIns="0" bIns="0" rtlCol="0" anchor="t"/>
+          <a:lstStyle/>
+          <a:p>
+            <a:pPr indent="0" marL="0">
+              <a:spcAft>
+                <a:spcPts val="1000"/>
+              </a:spcAft>
+              <a:buNone/>
+            </a:pPr>
+            <a:r>
+              <a:rPr lang="en-US" sz="1800" b="1" dirty="0">
+                <a:solidFill>
+                  <a:schemeClr val="accent2"/>
+                </a:solidFill>
+              </a:rPr>
+              <a:t>Pruébalo gratis hoy en tu negocio.</a:t>
+            </a:r>
+            <a:endParaRPr lang="en-US" sz="1800" dirty="0"/>
+          </a:p>
+          <a:p>
+            <a:pPr indent="0" marL="0">
+              <a:spcAft>
+                <a:spcPts val="400"/>
+              </a:spcAft>
+              <a:buNone/>
+            </a:pPr>
+            <a:r>
+              <a:rPr lang="en-US" sz="1500" dirty="0">
+                <a:solidFill>
+                  <a:srgbClr val="34D399"/>
+                </a:solidFill>
+              </a:rPr>
+              <a:t>WhatsApp: +57 313 895 0277</a:t>
+            </a:r>
+            <a:endParaRPr lang="en-US" sz="1800" dirty="0"/>
+          </a:p>
+          <a:p>
+            <a:pPr indent="0" marL="0">
+              <a:buNone/>
+            </a:pPr>
+            <a:r>
+              <a:rPr lang="en-US" sz="1300" dirty="0">
+                <a:solidFill>
+                  <a:srgbClr val="A9A6BD"/>
+                </a:solidFill>
+              </a:rPr>
+              <a:t>cristhianlujan45-blip.github.io/cuentas</a:t>
+            </a:r>
+            <a:endParaRPr lang="en-US" sz="1800" dirty="0"/>
+          </a:p>
+        </p:txBody>
+      </p:sp>
+      <p:sp>
+        <p:nvSpPr>
+          <p:cNvPr id="5" name="Pantalla de cuenta marco"/>
+          <p:cNvSpPr/>
+          <p:nvPr/>
+        </p:nvSpPr>
+        <p:spPr>
+          <a:xfrm>
+            <a:off x="5925312" y="347472"/>
+            <a:ext cx="2135037" cy="4471416"/>
+          </a:xfrm>
+          <a:prstGeom prst="roundRect">
+            <a:avLst>
+              <a:gd name="adj" fmla="val 9422"/>
+            </a:avLst>
+          </a:prstGeom>
+          <a:solidFill>
+            <a:srgbClr val="05050A"/>
+          </a:solidFill>
+          <a:ln w="19050">
+            <a:solidFill>
+              <a:srgbClr val="4C3A8F"/>
+            </a:solidFill>
+            <a:prstDash val="solid"/>
+          </a:ln>
+          <a:effectLst>
+            <a:outerShdw sx="100000" sy="100000" kx="0" ky="0" algn="bl" rotWithShape="0" blurRad="228600" dist="25400" dir="5400000">
+              <a:srgbClr val="7C3AED">
+                <a:alpha val="35000"/>
+              </a:srgbClr>
+            </a:outerShdw>
+          </a:effectLst>
+        </p:spPr>
+      </p:sp>
+      <p:pic>
+        <p:nvPicPr>
+          <p:cNvPr id="6" name="Pantalla de cuenta" descr="preencoded.png">    </p:cNvPr>
+          <p:cNvPicPr>
+            <a:picLocks noChangeAspect="1"/>
+          </p:cNvPicPr>
+          <p:nvPr/>
+        </p:nvPicPr>
+        <p:blipFill>
+          <a:blip r:embed="rId2"/>
+          <a:stretch>
+            <a:fillRect/>
+          </a:stretch>
+        </p:blipFill>
+        <p:spPr>
+          <a:xfrm>
+            <a:off x="5989320" y="411480"/>
+            <a:ext cx="2007021" cy="4343400"/>
+          </a:xfrm>
+          <a:prstGeom prst="rect">
+            <a:avLst/>
+          </a:prstGeom>
+        </p:spPr>
+      </p:pic>
     </p:spTree>
   </p:cSld>
   <p:clrMapOvr>

</xml_diff>

<commit_message>
Inversionistas: modelo financiero (precios, presupuesto, proyecciones, uso de fondos) y pitch con equipo, precios, unidad económica, proyecciones y ronda
Co-Authored-By: Claude Opus 5.5 <noreply@anthropic.com>
Claude-Session: https://claude.ai/code/session_01264FeNVwnzWhYSciWxK2WJ
</commit_message>
<xml_diff>
--- a/ventas/Vento-presentacion.pptx
+++ b/ventas/Vento-presentacion.pptx
@@ -134,18 +134,18 @@
   <p:extLst>
     <p:ext uri="{521415D9-36F7-43E2-AB2F-B90AF26B5E84}">
       <p14:sectionLst xmlns:p14="http://schemas.microsoft.com/office/powerpoint/2010/main">
-        <p14:section name="Inicio" id="{844ddd31-f4fb-fa9c-6a02-c3b02b0b5b55}">
+        <p14:section name="Inicio" id="{8822ce26-1e4a-4596-24aa-f7b19e40ed8a}">
           <p14:sldIdLst>
             <p14:sldId id="256"/>
           </p14:sldIdLst>
         </p14:section>
-        <p14:section name="Problema y solución" id="{c89a5d2e-cd83-584a-b62c-a65082f08f37}">
+        <p14:section name="Problema y solución" id="{d5e01d69-b9d7-5e0f-db3c-e77fd14f4e8a}">
           <p14:sldIdLst>
             <p14:sldId id="257"/>
             <p14:sldId id="258"/>
           </p14:sldIdLst>
         </p14:section>
-        <p14:section name="Producto" id="{73a1b155-024e-0a63-ed39-18a09f054bb1}">
+        <p14:section name="Producto" id="{e413664c-5bf4-e156-51a4-fb2469ca684d}">
           <p14:sldIdLst>
             <p14:sldId id="259"/>
             <p14:sldId id="260"/>
@@ -157,14 +157,14 @@
             <p14:sldId id="266"/>
           </p14:sldIdLst>
         </p14:section>
-        <p14:section name="Administración" id="{1539417d-1462-f47a-09fb-052cf0bcd57c}">
+        <p14:section name="Administración" id="{c996afd1-4d0d-3a9b-521b-bd04e62e7da8}">
           <p14:sldIdLst>
             <p14:sldId id="267"/>
             <p14:sldId id="268"/>
             <p14:sldId id="269"/>
           </p14:sldIdLst>
         </p14:section>
-        <p14:section name="Operación" id="{bfed59b0-3d77-352b-a48e-a3425681e235}">
+        <p14:section name="Operación" id="{279b01e7-4ab9-1544-d9f3-4b5916893638}">
           <p14:sldIdLst>
             <p14:sldId id="270"/>
             <p14:sldId id="271"/>
@@ -172,14 +172,14 @@
             <p14:sldId id="273"/>
           </p14:sldIdLst>
         </p14:section>
-        <p14:section name="Negocio" id="{48b14e2d-cdd6-1799-6f24-b08d10bd0021}">
+        <p14:section name="Negocio" id="{87eee210-8e1a-16d8-0876-ce9b979552f3}">
           <p14:sldIdLst>
             <p14:sldId id="274"/>
             <p14:sldId id="275"/>
             <p14:sldId id="276"/>
           </p14:sldIdLst>
         </p14:section>
-        <p14:section name="Futuro y cierre" id="{deb28210-c6c0-8a58-57b6-cd027fef7fe0}">
+        <p14:section name="Futuro y cierre" id="{11a495dc-875b-5113-60d4-13fe8da57545}">
           <p14:sldIdLst>
             <p14:sldId id="277"/>
             <p14:sldId id="278"/>
@@ -26761,7 +26761,7 @@
                   <a:srgbClr val="C4B5FD"/>
                 </a:solidFill>
               </a:rPr>
-              <a:t>Como los QR de las pasarelas de pago, pero con tu Nequi y DaviPlata de siempre, y sin comisión.</a:t>
+              <a:t>Como el SonoQR de Bold, Vento anuncia en voz alta cada pago que llega, pero con tu Nequi y DaviPlata y sin comisión de Vento.</a:t>
             </a:r>
             <a:endParaRPr lang="en-US" sz="1150" dirty="0"/>
           </a:p>

</xml_diff>